<commit_message>
Correct carrier-blot evidence and confirmed-cis decision
</commit_message>
<xml_diff>
--- a/reports/media/jeweled_track2_slides.pptx
+++ b/reports/media/jeweled_track2_slides.pptx
@@ -549,7 +549,7 @@
           <a:lstStyle xmlns:a="http://schemas.openxmlformats.org/drawingml/2006/main"/>
           <a:p xmlns:a="http://schemas.openxmlformats.org/drawingml/2006/main">
             <a:r>
-              <a:t>Our leading genetic explanation involves Bub one B, the gene that makes the chromosome-checking protein Bub R one. One change creates an early stop. The other changes one amino acid. We still need to establish whether they occupy opposite gene copies, and whether the altered protein retains useful function.</a:t>
+              <a:t>Our genetic hypothesis involves Bub one B, which makes the chromosome-checking protein Bub R one. One variant creates an early stop. The other changes one amino acid. They must occupy opposite gene copies for this compound-heterozygous explanation. Confirmed cis means both share one copy and retires that explanation. The missense variant's function remains unproved.</a:t>
             </a:r>
           </a:p>
           <a:p xmlns:a="http://schemas.openxmlformats.org/drawingml/2006/main">
@@ -579,12 +579,27 @@
           </a:p>
           <a:p xmlns:a="http://schemas.openxmlformats.org/drawingml/2006/main">
             <a:r>
+              <a:t>reports/appendices/causal-interpretation.md</a:t>
+            </a:r>
+          </a:p>
+          <a:p xmlns:a="http://schemas.openxmlformats.org/drawingml/2006/main">
+            <a:r>
               <a:t/>
             </a:r>
           </a:p>
           <a:p xmlns:a="http://schemas.openxmlformats.org/drawingml/2006/main">
             <a:r>
               <a:t>Research proposal. No biological drug experiment has been performed. Narration: Cartesia Sonic 3.6, stock Skylar. Image on cover is AI-generated conceptual artwork, not biological evidence.</a:t>
+            </a:r>
+          </a:p>
+          <a:p xmlns:a="http://schemas.openxmlformats.org/drawingml/2006/main">
+            <a:r>
+              <a:t/>
+            </a:r>
+          </a:p>
+          <a:p xmlns:a="http://schemas.openxmlformats.org/drawingml/2006/main">
+            <a:r>
+              <a:t>Confirmed cis [L737Ter;N1002K]/WT retires these two variants as a compound-heterozygous or biallelic MVA1 explanation. A different case rationale requires a separately demonstrated additional pathogenic allele in trans, on the opposite homolog, or an independently demonstrated dominant mechanism. Either would support a different causal hypothesis and would not make this cis pair compound heterozygous. N1002K remains a variant of uncertain significance.</a:t>
             </a:r>
           </a:p>
         </p:txBody>
@@ -654,7 +669,7 @@
           <a:lstStyle xmlns:a="http://schemas.openxmlformats.org/drawingml/2006/main"/>
           <a:p xmlns:a="http://schemas.openxmlformats.org/drawingml/2006/main">
             <a:r>
-              <a:t>Our first hypothesis is everolimus. It inhibits em tor complex one, a pathway that regulates cell growth. Its established target and pediatric use make it practical to investigate. A different Bub one B mouse model showed increased pathway activity, but tested no drug rescue. We must establish harmful excess signaling and useful muscle benefit.</a:t>
+              <a:t>Everolimus inhibits em tor complex one, which regulates cell growth. Its established target makes it practical to test. The supporting mouse blot shows stronger phosphoprotein bands in two single-allele carriers than two controls. Without matching total-protein measurements, quantification or statistical tests, increased pathway activity is unproved. Harmful excess and useful muscle benefit still need testing.</a:t>
             </a:r>
           </a:p>
           <a:p xmlns:a="http://schemas.openxmlformats.org/drawingml/2006/main">
@@ -690,6 +705,16 @@
           <a:p xmlns:a="http://schemas.openxmlformats.org/drawingml/2006/main">
             <a:r>
               <a:t>Research proposal. No biological drug experiment has been performed. Narration: Cartesia Sonic 3.6, stock Skylar. Image on cover is AI-generated conceptual artwork, not biological evidence.</a:t>
+            </a:r>
+          </a:p>
+          <a:p xmlns:a="http://schemas.openxmlformats.org/drawingml/2006/main">
+            <a:r>
+              <a:t/>
+            </a:r>
+          </a:p>
+          <a:p xmlns:a="http://schemas.openxmlformats.org/drawingml/2006/main">
+            <a:r>
+              <a:t>Sieben et al. 2020, Figure 5C: visually stronger phospho-S6K and phospho-4EBP1 bands in two BubR1+/X753 monoallelic carrier mice versus two WT mice. Ponceau S is a loading control; the panel supplies no matching total S6K or total 4EBP1 denominators, quantification, or statistical inference. This qualitative blot does not establish increased pathway activity. No drug rescue is tested.</a:t>
             </a:r>
           </a:p>
         </p:txBody>
@@ -2169,7 +2194,7 @@
           <p:cNvPr id="6" name="">
             <a:extLst xmlns:a="http://schemas.openxmlformats.org/drawingml/2006/main">
               <a:ext uri="{FF2B5EF4-FFF2-40B4-BE49-F238E27FC236}">
-                <a16:creationId xmlns:a16="http://schemas.microsoft.com/office/drawing/2014/main" id="{FD6BC8A4-A392-48AE-94D2-8B9F21CB9D8B}"/>
+                <a16:creationId xmlns:a16="http://schemas.microsoft.com/office/drawing/2014/main" id="{D7AF03FE-CB9A-4AA0-B778-FC61B372C931}"/>
               </a:ext>
             </a:extLst>
           </p:cNvPr>
@@ -2226,7 +2251,7 @@
           <p:cNvPr id="2" name="">
             <a:extLst xmlns:a="http://schemas.openxmlformats.org/drawingml/2006/main">
               <a:ext uri="{FF2B5EF4-FFF2-40B4-BE49-F238E27FC236}">
-                <a16:creationId xmlns:a16="http://schemas.microsoft.com/office/drawing/2014/main" id="{14786E67-FC2B-4380-B8FB-A10A39262A7E}"/>
+                <a16:creationId xmlns:a16="http://schemas.microsoft.com/office/drawing/2014/main" id="{EE865D98-086A-421B-B4B9-7A0C0F8BDE73}"/>
               </a:ext>
             </a:extLst>
           </p:cNvPr>
@@ -2283,7 +2308,7 @@
           <p:cNvPr id="3" name="">
             <a:extLst xmlns:a="http://schemas.openxmlformats.org/drawingml/2006/main">
               <a:ext uri="{FF2B5EF4-FFF2-40B4-BE49-F238E27FC236}">
-                <a16:creationId xmlns:a16="http://schemas.microsoft.com/office/drawing/2014/main" id="{AB215A93-F0CB-43B3-A012-6F810A1C0E23}"/>
+                <a16:creationId xmlns:a16="http://schemas.microsoft.com/office/drawing/2014/main" id="{A1C524AE-E60D-4F77-A22A-9EBFB3294755}"/>
               </a:ext>
             </a:extLst>
           </p:cNvPr>
@@ -2524,7 +2549,7 @@
           <p:cNvPr id="5" name="">
             <a:extLst xmlns:a="http://schemas.openxmlformats.org/drawingml/2006/main">
               <a:ext uri="{FF2B5EF4-FFF2-40B4-BE49-F238E27FC236}">
-                <a16:creationId xmlns:a16="http://schemas.microsoft.com/office/drawing/2014/main" id="{03ACBD0B-6ABE-473A-8CD7-1F71BAB84AF9}"/>
+                <a16:creationId xmlns:a16="http://schemas.microsoft.com/office/drawing/2014/main" id="{660B1C57-2577-4D2F-BAB6-C91848F3054B}"/>
               </a:ext>
             </a:extLst>
           </p:cNvPr>
@@ -2535,8 +2560,8 @@
         </p:nvSpPr>
         <p:spPr>
           <a:xfrm xmlns:a="http://schemas.openxmlformats.org/drawingml/2006/main">
-            <a:off x="685800" y="5343525"/>
-            <a:ext cx="10820400" cy="647700"/>
+            <a:off x="685800" y="5248275"/>
+            <a:ext cx="10820400" cy="962025"/>
           </a:xfrm>
           <a:prstGeom xmlns:a="http://schemas.openxmlformats.org/drawingml/2006/main" prst="rect">
             <a:avLst/>
@@ -2571,7 +2596,30 @@
                 <a:ea typeface="Aptos"/>
                 <a:cs typeface="Aptos"/>
               </a:rPr>
-              <a:t>Unresolved: opposite gene copies, residual protein and actual function.</a:t>
+              <a:t>Confirmed cis [L737Ter;N1002K]/WT retires this</a:t>
+            </a:r>
+          </a:p>
+          <a:p xmlns:a="http://schemas.openxmlformats.org/drawingml/2006/main">
+            <a:pPr>
+              <a:defRPr sz="2025" b="1">
+                <a:solidFill>
+                  <a:srgbClr val="167A78"/>
+                </a:solidFill>
+                <a:latin typeface="Aptos"/>
+                <a:ea typeface="Aptos"/>
+                <a:cs typeface="Aptos"/>
+              </a:defRPr>
+            </a:pPr>
+            <a:r>
+              <a:rPr sz="2025" b="1">
+                <a:solidFill>
+                  <a:srgbClr val="167A78"/>
+                </a:solidFill>
+                <a:latin typeface="Aptos"/>
+                <a:ea typeface="Aptos"/>
+                <a:cs typeface="Aptos"/>
+              </a:rPr>
+              <a:t>compound-heterozygous explanation.</a:t>
             </a:r>
           </a:p>
         </p:txBody>
@@ -2579,7 +2627,7 @@
     </p:spTree>
     <p:extLst>
       <p:ext uri="{BB962C8B-B14F-4D97-AF65-F5344CB8AC3E}">
-        <p14:creationId xmlns:p14="http://schemas.microsoft.com/office/powerpoint/2010/main" val="171621047"/>
+        <p14:creationId xmlns:p14="http://schemas.microsoft.com/office/powerpoint/2010/main" val="691428534"/>
       </p:ext>
     </p:extLst>
   </p:cSld>
@@ -2610,7 +2658,7 @@
           <p:cNvPr id="10" name="">
             <a:extLst xmlns:a="http://schemas.openxmlformats.org/drawingml/2006/main">
               <a:ext uri="{FF2B5EF4-FFF2-40B4-BE49-F238E27FC236}">
-                <a16:creationId xmlns:a16="http://schemas.microsoft.com/office/drawing/2014/main" id="{BC92F766-FCC1-4BD6-9302-B0B4F103E6E0}"/>
+                <a16:creationId xmlns:a16="http://schemas.microsoft.com/office/drawing/2014/main" id="{8DEE6D5E-595D-4C3B-9829-4BFBA424E893}"/>
               </a:ext>
             </a:extLst>
           </p:cNvPr>
@@ -2667,7 +2715,7 @@
           <p:cNvPr id="2" name="">
             <a:extLst xmlns:a="http://schemas.openxmlformats.org/drawingml/2006/main">
               <a:ext uri="{FF2B5EF4-FFF2-40B4-BE49-F238E27FC236}">
-                <a16:creationId xmlns:a16="http://schemas.microsoft.com/office/drawing/2014/main" id="{460510D7-5A6F-4C33-B8B6-52579B6B4D9D}"/>
+                <a16:creationId xmlns:a16="http://schemas.microsoft.com/office/drawing/2014/main" id="{75610479-4D6B-4AD8-B5BC-6DE7869B5935}"/>
               </a:ext>
             </a:extLst>
           </p:cNvPr>
@@ -2724,7 +2772,7 @@
           <p:cNvPr id="3" name="">
             <a:extLst xmlns:a="http://schemas.openxmlformats.org/drawingml/2006/main">
               <a:ext uri="{FF2B5EF4-FFF2-40B4-BE49-F238E27FC236}">
-                <a16:creationId xmlns:a16="http://schemas.microsoft.com/office/drawing/2014/main" id="{C27753E7-4A53-4B9A-8809-8883B61F5984}"/>
+                <a16:creationId xmlns:a16="http://schemas.microsoft.com/office/drawing/2014/main" id="{AE2F4C86-A8A0-4EE9-BF6A-CE7D269C0CF5}"/>
               </a:ext>
             </a:extLst>
           </p:cNvPr>
@@ -2781,7 +2829,7 @@
           <p:cNvPr id="4" name="">
             <a:extLst xmlns:a="http://schemas.openxmlformats.org/drawingml/2006/main">
               <a:ext uri="{FF2B5EF4-FFF2-40B4-BE49-F238E27FC236}">
-                <a16:creationId xmlns:a16="http://schemas.microsoft.com/office/drawing/2014/main" id="{FC4FD5D0-209E-426D-822E-11ED755A373D}"/>
+                <a16:creationId xmlns:a16="http://schemas.microsoft.com/office/drawing/2014/main" id="{10CD5A01-4553-4751-B921-AD1CB456D429}"/>
               </a:ext>
             </a:extLst>
           </p:cNvPr>
@@ -2838,7 +2886,7 @@
           <p:cNvPr id="5" name="">
             <a:extLst xmlns:a="http://schemas.openxmlformats.org/drawingml/2006/main">
               <a:ext uri="{FF2B5EF4-FFF2-40B4-BE49-F238E27FC236}">
-                <a16:creationId xmlns:a16="http://schemas.microsoft.com/office/drawing/2014/main" id="{76D74D4A-A192-4304-9719-55C3BCDFD079}"/>
+                <a16:creationId xmlns:a16="http://schemas.microsoft.com/office/drawing/2014/main" id="{525D8CBD-3710-465A-A024-C7DF5F5424C4}"/>
               </a:ext>
             </a:extLst>
           </p:cNvPr>
@@ -2895,7 +2943,7 @@
           <p:cNvPr id="6" name="">
             <a:extLst xmlns:a="http://schemas.openxmlformats.org/drawingml/2006/main">
               <a:ext uri="{FF2B5EF4-FFF2-40B4-BE49-F238E27FC236}">
-                <a16:creationId xmlns:a16="http://schemas.microsoft.com/office/drawing/2014/main" id="{1A76908B-3E01-4BF6-B265-A75BD3CDB476}"/>
+                <a16:creationId xmlns:a16="http://schemas.microsoft.com/office/drawing/2014/main" id="{6B65E5EB-60B3-4D4E-A857-083847F15C47}"/>
               </a:ext>
             </a:extLst>
           </p:cNvPr>
@@ -2906,8 +2954,8 @@
         </p:nvSpPr>
         <p:spPr>
           <a:xfrm xmlns:a="http://schemas.openxmlformats.org/drawingml/2006/main">
-            <a:off x="6286500" y="2381250"/>
-            <a:ext cx="5048250" cy="1257300"/>
+            <a:off x="6286500" y="2314575"/>
+            <a:ext cx="5048250" cy="1600200"/>
           </a:xfrm>
           <a:prstGeom xmlns:a="http://schemas.openxmlformats.org/drawingml/2006/main" prst="rect">
             <a:avLst/>
@@ -2924,7 +2972,7 @@
           <a:lstStyle xmlns:a="http://schemas.openxmlformats.org/drawingml/2006/main"/>
           <a:p xmlns:a="http://schemas.openxmlformats.org/drawingml/2006/main">
             <a:pPr>
-              <a:defRPr sz="2400" b="0">
+              <a:defRPr sz="2250" b="0">
                 <a:solidFill>
                   <a:srgbClr val="102E36"/>
                 </a:solidFill>
@@ -2934,7 +2982,7 @@
               </a:defRPr>
             </a:pPr>
             <a:r>
-              <a:rPr sz="2400" b="0">
+              <a:rPr sz="2250" b="0">
                 <a:solidFill>
                   <a:srgbClr val="102E36"/>
                 </a:solidFill>
@@ -2942,7 +2990,53 @@
                 <a:ea typeface="Aptos"/>
                 <a:cs typeface="Aptos"/>
               </a:rPr>
-              <a:t>Increased muscle pathway activity in a different BUB1B mouse model</a:t>
+              <a:t>Visually stronger pS6K / p4EBP1 bands</a:t>
+            </a:r>
+          </a:p>
+          <a:p xmlns:a="http://schemas.openxmlformats.org/drawingml/2006/main">
+            <a:pPr>
+              <a:defRPr sz="2250" b="0">
+                <a:solidFill>
+                  <a:srgbClr val="102E36"/>
+                </a:solidFill>
+                <a:latin typeface="Aptos"/>
+                <a:ea typeface="Aptos"/>
+                <a:cs typeface="Aptos"/>
+              </a:defRPr>
+            </a:pPr>
+            <a:r>
+              <a:rPr sz="2250" b="0">
+                <a:solidFill>
+                  <a:srgbClr val="102E36"/>
+                </a:solidFill>
+                <a:latin typeface="Aptos"/>
+                <a:ea typeface="Aptos"/>
+                <a:cs typeface="Aptos"/>
+              </a:rPr>
+              <a:t>BubR1+/X753 versus WT</a:t>
+            </a:r>
+          </a:p>
+          <a:p xmlns:a="http://schemas.openxmlformats.org/drawingml/2006/main">
+            <a:pPr>
+              <a:defRPr sz="2250" b="0">
+                <a:solidFill>
+                  <a:srgbClr val="102E36"/>
+                </a:solidFill>
+                <a:latin typeface="Aptos"/>
+                <a:ea typeface="Aptos"/>
+                <a:cs typeface="Aptos"/>
+              </a:defRPr>
+            </a:pPr>
+            <a:r>
+              <a:rPr sz="2250" b="0">
+                <a:solidFill>
+                  <a:srgbClr val="102E36"/>
+                </a:solidFill>
+                <a:latin typeface="Aptos"/>
+                <a:ea typeface="Aptos"/>
+                <a:cs typeface="Aptos"/>
+              </a:rPr>
+              <a:t>Two mice per genotype</a:t>
             </a:r>
           </a:p>
         </p:txBody>
@@ -2952,7 +3046,7 @@
           <p:cNvPr id="7" name="">
             <a:extLst xmlns:a="http://schemas.openxmlformats.org/drawingml/2006/main">
               <a:ext uri="{FF2B5EF4-FFF2-40B4-BE49-F238E27FC236}">
-                <a16:creationId xmlns:a16="http://schemas.microsoft.com/office/drawing/2014/main" id="{BFA5066F-500F-4C5F-B259-53EEDE4D1D76}"/>
+                <a16:creationId xmlns:a16="http://schemas.microsoft.com/office/drawing/2014/main" id="{C6AAF6BA-2CB7-4692-A1EE-56D61490A9EC}"/>
               </a:ext>
             </a:extLst>
           </p:cNvPr>
@@ -3009,7 +3103,7 @@
           <p:cNvPr id="8" name="">
             <a:extLst xmlns:a="http://schemas.openxmlformats.org/drawingml/2006/main">
               <a:ext uri="{FF2B5EF4-FFF2-40B4-BE49-F238E27FC236}">
-                <a16:creationId xmlns:a16="http://schemas.microsoft.com/office/drawing/2014/main" id="{2A07E321-0352-49C2-8B5C-E9D44E89B138}"/>
+                <a16:creationId xmlns:a16="http://schemas.microsoft.com/office/drawing/2014/main" id="{9D180964-4EDC-40BB-89BA-11A5EB08A0CA}"/>
               </a:ext>
             </a:extLst>
           </p:cNvPr>
@@ -3020,8 +3114,8 @@
         </p:nvSpPr>
         <p:spPr>
           <a:xfrm xmlns:a="http://schemas.openxmlformats.org/drawingml/2006/main">
-            <a:off x="6286500" y="4552950"/>
-            <a:ext cx="5048250" cy="1209675"/>
+            <a:off x="6286500" y="4486275"/>
+            <a:ext cx="5048250" cy="1333500"/>
           </a:xfrm>
           <a:prstGeom xmlns:a="http://schemas.openxmlformats.org/drawingml/2006/main" prst="rect">
             <a:avLst/>
@@ -3056,7 +3150,7 @@
                 <a:ea typeface="Aptos"/>
                 <a:cs typeface="Aptos"/>
               </a:rPr>
-              <a:t>Proof that this causes harm here, and that everolimus restores function</a:t>
+              <a:t>Pathway hyperactivity, harmful excess and useful muscle benefit remain unproved</a:t>
             </a:r>
           </a:p>
         </p:txBody>
@@ -3066,7 +3160,7 @@
           <p:cNvPr id="9" name="">
             <a:extLst xmlns:a="http://schemas.openxmlformats.org/drawingml/2006/main">
               <a:ext uri="{FF2B5EF4-FFF2-40B4-BE49-F238E27FC236}">
-                <a16:creationId xmlns:a16="http://schemas.microsoft.com/office/drawing/2014/main" id="{08DF3B27-A014-4616-B9D2-1D4672673067}"/>
+                <a16:creationId xmlns:a16="http://schemas.microsoft.com/office/drawing/2014/main" id="{02678E2D-02C6-4C36-8167-03523F2B3B6C}"/>
               </a:ext>
             </a:extLst>
           </p:cNvPr>
@@ -3078,7 +3172,7 @@
         <p:spPr>
           <a:xfrm xmlns:a="http://schemas.openxmlformats.org/drawingml/2006/main">
             <a:off x="685800" y="6067425"/>
-            <a:ext cx="9906000" cy="400050"/>
+            <a:ext cx="10572750" cy="400050"/>
           </a:xfrm>
           <a:prstGeom xmlns:a="http://schemas.openxmlformats.org/drawingml/2006/main" prst="rect">
             <a:avLst/>
@@ -3113,7 +3207,7 @@
                 <a:ea typeface="Aptos"/>
                 <a:cs typeface="Aptos"/>
               </a:rPr>
-              <a:t>Small signaling study: two mice per genotype. No drug rescue tested.</a:t>
+              <a:t>No phospho/total ratios, quantification or statistical tests. No drug rescue.</a:t>
             </a:r>
           </a:p>
         </p:txBody>
@@ -3121,7 +3215,7 @@
     </p:spTree>
     <p:extLst>
       <p:ext uri="{BB962C8B-B14F-4D97-AF65-F5344CB8AC3E}">
-        <p14:creationId xmlns:p14="http://schemas.microsoft.com/office/powerpoint/2010/main" val="643100907"/>
+        <p14:creationId xmlns:p14="http://schemas.microsoft.com/office/powerpoint/2010/main" val="2020503096"/>
       </p:ext>
     </p:extLst>
   </p:cSld>

</xml_diff>

<commit_message>
Prioritize niacin and demonstrate Track 2 workflow reuse
</commit_message>
<xml_diff>
--- a/reports/media/jeweled_track2_slides.pptx
+++ b/reports/media/jeweled_track2_slides.pptx
@@ -2,20 +2,20 @@
 <file path=ppt/presentation.xml><?xml version="1.0" encoding="utf-8"?>
 <p:presentation xmlns:p="http://schemas.openxmlformats.org/presentationml/2006/main">
   <p:sldMasterIdLst>
-    <p:sldMasterId xmlns:r="http://schemas.openxmlformats.org/officeDocument/2006/relationships" id="2147483648" r:id="R8e4f1940dbd44954"/>
+    <p:sldMasterId xmlns:r="http://schemas.openxmlformats.org/officeDocument/2006/relationships" id="2147483648" r:id="R5a651e2cc8be4ae4"/>
   </p:sldMasterIdLst>
   <p:notesMasterIdLst>
-    <p:notesMasterId xmlns:r="http://schemas.openxmlformats.org/officeDocument/2006/relationships" r:id="Rb90c22404b26411b"/>
+    <p:notesMasterId xmlns:r="http://schemas.openxmlformats.org/officeDocument/2006/relationships" r:id="R00c31f57320247b5"/>
   </p:notesMasterIdLst>
   <p:sldIdLst>
-    <p:sldId xmlns:r="http://schemas.openxmlformats.org/officeDocument/2006/relationships" id="256" r:id="R537a987eca35469f"/>
-    <p:sldId xmlns:r="http://schemas.openxmlformats.org/officeDocument/2006/relationships" id="257" r:id="Rea22d91b60b548e0"/>
-    <p:sldId xmlns:r="http://schemas.openxmlformats.org/officeDocument/2006/relationships" id="258" r:id="Rdb70a9f803cf4cbf"/>
-    <p:sldId xmlns:r="http://schemas.openxmlformats.org/officeDocument/2006/relationships" id="259" r:id="Rbb26451c96f94af3"/>
-    <p:sldId xmlns:r="http://schemas.openxmlformats.org/officeDocument/2006/relationships" id="260" r:id="Re1cfc4bee8c24799"/>
-    <p:sldId xmlns:r="http://schemas.openxmlformats.org/officeDocument/2006/relationships" id="261" r:id="Re0a0512db2314f75"/>
-    <p:sldId xmlns:r="http://schemas.openxmlformats.org/officeDocument/2006/relationships" id="262" r:id="Rcbdb1b7908f742f6"/>
-    <p:sldId xmlns:r="http://schemas.openxmlformats.org/officeDocument/2006/relationships" id="263" r:id="Re03566e08fad4e21"/>
+    <p:sldId xmlns:r="http://schemas.openxmlformats.org/officeDocument/2006/relationships" id="256" r:id="R5c49f40aa19541bc"/>
+    <p:sldId xmlns:r="http://schemas.openxmlformats.org/officeDocument/2006/relationships" id="257" r:id="R0d4f3e76154049bd"/>
+    <p:sldId xmlns:r="http://schemas.openxmlformats.org/officeDocument/2006/relationships" id="258" r:id="Ref02a9c6f2704ca4"/>
+    <p:sldId xmlns:r="http://schemas.openxmlformats.org/officeDocument/2006/relationships" id="259" r:id="R99aabc55bfbb4c0c"/>
+    <p:sldId xmlns:r="http://schemas.openxmlformats.org/officeDocument/2006/relationships" id="260" r:id="Rf90daa3f5d82406c"/>
+    <p:sldId xmlns:r="http://schemas.openxmlformats.org/officeDocument/2006/relationships" id="261" r:id="R45dd65b31e47470c"/>
+    <p:sldId xmlns:r="http://schemas.openxmlformats.org/officeDocument/2006/relationships" id="262" r:id="Rd3c56b7ef7bc466f"/>
+    <p:sldId xmlns:r="http://schemas.openxmlformats.org/officeDocument/2006/relationships" id="263" r:id="R0573f7a4efc64754"/>
   </p:sldIdLst>
   <p:sldSz cx="12192000" cy="6858000"/>
   <p:notesSz cx="6858000" cy="9144000"/>
@@ -479,7 +479,7 @@
           </a:p>
           <a:p xmlns:a="http://schemas.openxmlformats.org/drawingml/2006/main">
             <a:r>
-              <a:t>Research proposal. No biological drug experiment has been performed. Narration: Cartesia Sonic 3.6, stock Skylar. Image on cover is AI-generated conceptual artwork, not biological evidence.</a:t>
+              <a:t>Research proposal. No biological drug experiment has run. Synthetic TRIP13 is a public transfer demonstration, not a second analyzed patient. Niacin has no demonstrated BUB1B rescue. Narration: Cartesia Sonic 3.6, stock Skylar.</a:t>
             </a:r>
           </a:p>
         </p:txBody>
@@ -549,7 +549,7 @@
           <a:lstStyle xmlns:a="http://schemas.openxmlformats.org/drawingml/2006/main"/>
           <a:p xmlns:a="http://schemas.openxmlformats.org/drawingml/2006/main">
             <a:r>
-              <a:t>Our genetic hypothesis involves Bub one B, which makes the chromosome-checking protein Bub R one. One variant creates an early stop. The other changes one amino acid. They must occupy opposite gene copies for this compound-heterozygous explanation. Confirmed cis means both share one copy and retires that explanation. The missense variant's function remains unproved.</a:t>
+              <a:t>Bub one B makes the checkpoint protein Bub R one. Our stop-plus-missense pair matches a reported MVA one pattern: reduced protein supply. The missense protein's stability and function remain unmeasured. Trans phase needs confirmation. Confirmed cis retires this pair as the compound-heterozygous explanation.</a:t>
             </a:r>
           </a:p>
           <a:p xmlns:a="http://schemas.openxmlformats.org/drawingml/2006/main">
@@ -589,17 +589,7 @@
           </a:p>
           <a:p xmlns:a="http://schemas.openxmlformats.org/drawingml/2006/main">
             <a:r>
-              <a:t>Research proposal. No biological drug experiment has been performed. Narration: Cartesia Sonic 3.6, stock Skylar. Image on cover is AI-generated conceptual artwork, not biological evidence.</a:t>
-            </a:r>
-          </a:p>
-          <a:p xmlns:a="http://schemas.openxmlformats.org/drawingml/2006/main">
-            <a:r>
-              <a:t/>
-            </a:r>
-          </a:p>
-          <a:p xmlns:a="http://schemas.openxmlformats.org/drawingml/2006/main">
-            <a:r>
-              <a:t>Confirmed cis [L737Ter;N1002K]/WT retires these two variants as a compound-heterozygous or biallelic MVA1 explanation. A different case rationale requires a separately demonstrated additional pathogenic allele in trans, on the opposite homolog, or an independently demonstrated dominant mechanism. Either would support a different causal hypothesis and would not make this cis pair compound heterozygous. N1002K remains a variant of uncertain significance.</a:t>
+              <a:t>Research proposal. No biological drug experiment has run. Synthetic TRIP13 is a public transfer demonstration, not a second analyzed patient. Niacin has no demonstrated BUB1B rescue. Narration: Cartesia Sonic 3.6, stock Skylar.</a:t>
             </a:r>
           </a:p>
         </p:txBody>
@@ -669,7 +659,7 @@
           <a:lstStyle xmlns:a="http://schemas.openxmlformats.org/drawingml/2006/main"/>
           <a:p xmlns:a="http://schemas.openxmlformats.org/drawingml/2006/main">
             <a:r>
-              <a:t>Everolimus inhibits em tor complex one, which regulates cell growth. Its established target makes it practical to test. The supporting mouse blot shows stronger phosphoprotein bands in two single-allele carriers than two controls. Without matching total-protein measurements, quantification or statistical tests, increased pathway activity is unproved. Harmful excess and useful muscle benefit still need testing.</a:t>
+              <a:t>Niacin is our lead because it targets the protein-supply hypothesis. It raised muscle N A D in another myopathy. Separate experiments connect N A D and SIRT two to Bub R one stability. Niacin has not rescued this genotype. We test whether it increases usable protein and useful muscle.</a:t>
             </a:r>
           </a:p>
           <a:p xmlns:a="http://schemas.openxmlformats.org/drawingml/2006/main">
@@ -684,17 +674,17 @@
           </a:p>
           <a:p xmlns:a="http://schemas.openxmlformats.org/drawingml/2006/main">
             <a:r>
-              <a:t>https://www.jci.org/articles/view/126863/version/2</a:t>
-            </a:r>
-          </a:p>
-          <a:p xmlns:a="http://schemas.openxmlformats.org/drawingml/2006/main">
-            <a:r>
-              <a:t>https://dailymed.nlm.nih.gov/dailymed/fda/fdaDrugXsl.cfm?setid=2150f73a-179b-4afc-b8ce-67c85cc72f04</a:t>
-            </a:r>
-          </a:p>
-          <a:p xmlns:a="http://schemas.openxmlformats.org/drawingml/2006/main">
-            <a:r>
-              <a:t>reports/appendices/track2-evidence-pipeline.md</a:t>
+              <a:t>https://pubmed.ncbi.nlm.nih.gov/32386566/</a:t>
+            </a:r>
+          </a:p>
+          <a:p xmlns:a="http://schemas.openxmlformats.org/drawingml/2006/main">
+            <a:r>
+              <a:t>https://pmc.ncbi.nlm.nih.gov/articles/PMC4194088/</a:t>
+            </a:r>
+          </a:p>
+          <a:p xmlns:a="http://schemas.openxmlformats.org/drawingml/2006/main">
+            <a:r>
+              <a:t>https://pubmed.ncbi.nlm.nih.gov/39173541/</a:t>
             </a:r>
           </a:p>
           <a:p xmlns:a="http://schemas.openxmlformats.org/drawingml/2006/main">
@@ -704,17 +694,7 @@
           </a:p>
           <a:p xmlns:a="http://schemas.openxmlformats.org/drawingml/2006/main">
             <a:r>
-              <a:t>Research proposal. No biological drug experiment has been performed. Narration: Cartesia Sonic 3.6, stock Skylar. Image on cover is AI-generated conceptual artwork, not biological evidence.</a:t>
-            </a:r>
-          </a:p>
-          <a:p xmlns:a="http://schemas.openxmlformats.org/drawingml/2006/main">
-            <a:r>
-              <a:t/>
-            </a:r>
-          </a:p>
-          <a:p xmlns:a="http://schemas.openxmlformats.org/drawingml/2006/main">
-            <a:r>
-              <a:t>Sieben et al. 2020, Figure 5C: visually stronger phospho-S6K and phospho-4EBP1 bands in two BubR1+/X753 monoallelic carrier mice versus two WT mice. Ponceau S is a loading control; the panel supplies no matching total S6K or total 4EBP1 denominators, quantification, or statistical inference. This qualitative blot does not establish increased pathway activity. No drug rescue is tested.</a:t>
+              <a:t>Research proposal. No biological drug experiment has run. Synthetic TRIP13 is a public transfer demonstration, not a second analyzed patient. Niacin has no demonstrated BUB1B rescue. Narration: Cartesia Sonic 3.6, stock Skylar.</a:t>
             </a:r>
           </a:p>
         </p:txBody>
@@ -784,7 +764,7 @@
           <a:lstStyle xmlns:a="http://schemas.openxmlformats.org/drawingml/2006/main"/>
           <a:p xmlns:a="http://schemas.openxmlformats.org/drawingml/2006/main">
             <a:r>
-              <a:t>Our challenger is niacin, the nicotinic acid medicine. It increased muscle N A D in a small study of another disease. Separate experiments connect N A D and the enzyme SIRT two to Bub R one stability. The missing link is whether niacin restores useful protein and muscle function in this genotype. We test the medicines separately.</a:t>
+              <a:t>Everolimus is our downstream probe. It inhibits em tor complex one, a growth pathway. A small carrier-mouse blot showed stronger phosphoprotein bands, without quantified pathway activity. Rapamycin preserved stem-cell numbers in a different fly model. Neither establishes muscle rescue. We require functional benefit with preserved growth and renewal.</a:t>
             </a:r>
           </a:p>
           <a:p xmlns:a="http://schemas.openxmlformats.org/drawingml/2006/main">
@@ -799,17 +779,22 @@
           </a:p>
           <a:p xmlns:a="http://schemas.openxmlformats.org/drawingml/2006/main">
             <a:r>
-              <a:t>https://pubmed.ncbi.nlm.nih.gov/32386566/</a:t>
-            </a:r>
-          </a:p>
-          <a:p xmlns:a="http://schemas.openxmlformats.org/drawingml/2006/main">
-            <a:r>
-              <a:t>https://pmc.ncbi.nlm.nih.gov/articles/PMC4194088/</a:t>
-            </a:r>
-          </a:p>
-          <a:p xmlns:a="http://schemas.openxmlformats.org/drawingml/2006/main">
-            <a:r>
-              <a:t>https://pubmed.ncbi.nlm.nih.gov/39173541/</a:t>
+              <a:t>https://www.jci.org/articles/view/126863/version/2</a:t>
+            </a:r>
+          </a:p>
+          <a:p xmlns:a="http://schemas.openxmlformats.org/drawingml/2006/main">
+            <a:r>
+              <a:t>https://dailymed.nlm.nih.gov/dailymed/fda/fdaDrugXsl.cfm?setid=2150f73a-179b-4afc-b8ce-67c85cc72f04</a:t>
+            </a:r>
+          </a:p>
+          <a:p xmlns:a="http://schemas.openxmlformats.org/drawingml/2006/main">
+            <a:r>
+              <a:t>reports/appendices/track2-evidence-pipeline.md</a:t>
+            </a:r>
+          </a:p>
+          <a:p xmlns:a="http://schemas.openxmlformats.org/drawingml/2006/main">
+            <a:r>
+              <a:t>https://pmc.ncbi.nlm.nih.gov/articles/PMC13121444/</a:t>
             </a:r>
           </a:p>
           <a:p xmlns:a="http://schemas.openxmlformats.org/drawingml/2006/main">
@@ -819,7 +804,7 @@
           </a:p>
           <a:p xmlns:a="http://schemas.openxmlformats.org/drawingml/2006/main">
             <a:r>
-              <a:t>Research proposal. No biological drug experiment has been performed. Narration: Cartesia Sonic 3.6, stock Skylar. Image on cover is AI-generated conceptual artwork, not biological evidence.</a:t>
+              <a:t>Research proposal. No biological drug experiment has run. Synthetic TRIP13 is a public transfer demonstration, not a second analyzed patient. Niacin has no demonstrated BUB1B rescue. Narration: Cartesia Sonic 3.6, stock Skylar.</a:t>
             </a:r>
           </a:p>
         </p:txBody>
@@ -889,7 +874,7 @@
           <a:lstStyle xmlns:a="http://schemas.openxmlformats.org/drawingml/2006/main"/>
           <a:p xmlns:a="http://schemas.openxmlformats.org/drawingml/2006/main">
             <a:r>
-              <a:t>Our completed computer model shows why percentages can mislead. In one assumed scenario, removing abnormal cells improved the chromosome-normal fraction while reducing total muscle-cell output over time. These are simulated results, not drug effects. Our experiment therefore follows each starting cell, including those that die or stop dividing.</a:t>
+              <a:t>Our cell-selection explorer exposes a misleading result. In one simulated scenario, the chromosome-normal fraction rose sixteen point eight percentage points while total differentiated-cell time fell eleven percent. Other teams can inspect this tradeoff across declared assumptions. Our proposed experiment tracks starting cells, including those that die or stop dividing.</a:t>
             </a:r>
           </a:p>
           <a:p xmlns:a="http://schemas.openxmlformats.org/drawingml/2006/main">
@@ -919,12 +904,17 @@
           </a:p>
           <a:p xmlns:a="http://schemas.openxmlformats.org/drawingml/2006/main">
             <a:r>
+              <a:t>workflow/track2-model/explorer/index.html</a:t>
+            </a:r>
+          </a:p>
+          <a:p xmlns:a="http://schemas.openxmlformats.org/drawingml/2006/main">
+            <a:r>
               <a:t/>
             </a:r>
           </a:p>
           <a:p xmlns:a="http://schemas.openxmlformats.org/drawingml/2006/main">
             <a:r>
-              <a:t>Research proposal. No biological drug experiment has been performed. Narration: Cartesia Sonic 3.6, stock Skylar. Image on cover is AI-generated conceptual artwork, not biological evidence.</a:t>
+              <a:t>Research proposal. No biological drug experiment has run. Synthetic TRIP13 is a public transfer demonstration, not a second analyzed patient. Niacin has no demonstrated BUB1B rescue. Narration: Cartesia Sonic 3.6, stock Skylar.</a:t>
             </a:r>
           </a:p>
         </p:txBody>
@@ -1019,7 +1009,7 @@
           </a:p>
           <a:p xmlns:a="http://schemas.openxmlformats.org/drawingml/2006/main">
             <a:r>
-              <a:t>Research proposal. No biological drug experiment has been performed. Narration: Cartesia Sonic 3.6, stock Skylar. Image on cover is AI-generated conceptual artwork, not biological evidence.</a:t>
+              <a:t>Research proposal. No biological drug experiment has run. Synthetic TRIP13 is a public transfer demonstration, not a second analyzed patient. Niacin has no demonstrated BUB1B rescue. Narration: Cartesia Sonic 3.6, stock Skylar.</a:t>
             </a:r>
           </a:p>
         </p:txBody>
@@ -1124,7 +1114,7 @@
           </a:p>
           <a:p xmlns:a="http://schemas.openxmlformats.org/drawingml/2006/main">
             <a:r>
-              <a:t>Research proposal. No biological drug experiment has been performed. Narration: Cartesia Sonic 3.6, stock Skylar. Image on cover is AI-generated conceptual artwork, not biological evidence.</a:t>
+              <a:t>Research proposal. No biological drug experiment has run. Synthetic TRIP13 is a public transfer demonstration, not a second analyzed patient. Niacin has no demonstrated BUB1B rescue. Narration: Cartesia Sonic 3.6, stock Skylar.</a:t>
             </a:r>
           </a:p>
         </p:txBody>
@@ -1194,7 +1184,7 @@
           <a:lstStyle xmlns:a="http://schemas.openxmlformats.org/drawingml/2006/main"/>
           <a:p xmlns:a="http://schemas.openxmlformats.org/drawingml/2006/main">
             <a:r>
-              <a:t>We have completed sequence review, evidence review and computational study design. No biological drug experiment has run. We seek a consented cell model and laboratory partner. The deliverable is a reproducible decision: advance a medicine with measured functional benefit, or explain why none passes. The method can then be tested in other chromosome-instability disorders.</a:t>
+              <a:t>We also ran the workflow on a public, synthetic TRIP thirteen example. It shows why a Bub R one restoration hypothesis cannot simply transfer to another gene. That demonstrates reuse, not treatment validation. Next we need a consented muscle model and laboratory partner to test niacin, with everolimus as comparator.</a:t>
             </a:r>
           </a:p>
           <a:p xmlns:a="http://schemas.openxmlformats.org/drawingml/2006/main">
@@ -1219,12 +1209,17 @@
           </a:p>
           <a:p xmlns:a="http://schemas.openxmlformats.org/drawingml/2006/main">
             <a:r>
+              <a:t>workflow/track2-transfer/README.md</a:t>
+            </a:r>
+          </a:p>
+          <a:p xmlns:a="http://schemas.openxmlformats.org/drawingml/2006/main">
+            <a:r>
               <a:t/>
             </a:r>
           </a:p>
           <a:p xmlns:a="http://schemas.openxmlformats.org/drawingml/2006/main">
             <a:r>
-              <a:t>Research proposal. No biological drug experiment has been performed. Narration: Cartesia Sonic 3.6, stock Skylar. Image on cover is AI-generated conceptual artwork, not biological evidence.</a:t>
+              <a:t>Research proposal. No biological drug experiment has run. Synthetic TRIP13 is a public transfer demonstration, not a second analyzed patient. Niacin has no demonstrated BUB1B rescue. Narration: Cartesia Sonic 3.6, stock Skylar.</a:t>
             </a:r>
           </a:p>
         </p:txBody>
@@ -1292,7 +1287,7 @@
   </p:cSld>
   <p:clrMap bg1="lt1" tx1="dk1" bg2="lt2" tx2="dk2" accent1="accent1" accent2="accent2" accent3="accent3" accent4="accent4" accent5="accent5" accent6="accent6" hlink="hlink" folHlink="folHlink"/>
   <p:sldLayoutIdLst>
-    <p:sldLayoutId xmlns:r="http://schemas.openxmlformats.org/officeDocument/2006/relationships" id="2147483649" r:id="R48084e54d78941e4"/>
+    <p:sldLayoutId xmlns:r="http://schemas.openxmlformats.org/officeDocument/2006/relationships" id="2147483649" r:id="R36b2a6ad9b224e9f"/>
   </p:sldLayoutIdLst>
   <p:txStyles>
     <p:titleStyle>
@@ -1872,6 +1867,7 @@
           <a:lstStyle xmlns:a="http://schemas.openxmlformats.org/drawingml/2006/main"/>
           <a:p xmlns:a="http://schemas.openxmlformats.org/drawingml/2006/main">
             <a:pPr>
+              <a:buNone/>
               <a:defRPr sz="1350" b="0">
                 <a:solidFill>
                   <a:srgbClr val="48636A"/>
@@ -1897,14 +1893,14 @@
       </p:sp>
       <p:pic>
         <p:nvPicPr>
-          <p:cNvPr id="7" name=""/>
+          <p:cNvPr id="9" name=""/>
           <p:cNvPicPr>
             <a:picLocks xmlns:a="http://schemas.openxmlformats.org/drawingml/2006/main" noChangeAspect="1"/>
           </p:cNvPicPr>
           <p:nvPr/>
         </p:nvPicPr>
         <p:blipFill>
-          <a:blip xmlns:r="http://schemas.openxmlformats.org/officeDocument/2006/relationships" xmlns:a="http://schemas.openxmlformats.org/drawingml/2006/main" r:embed="R6b87a7c1ca98479d"/>
+          <a:blip xmlns:r="http://schemas.openxmlformats.org/officeDocument/2006/relationships" xmlns:a="http://schemas.openxmlformats.org/drawingml/2006/main" r:embed="R043c97924d484d44"/>
           <a:srcRect xmlns:a="http://schemas.openxmlformats.org/drawingml/2006/main" l="0" t="27" r="0" b="27"/>
           <a:stretch xmlns:a="http://schemas.openxmlformats.org/drawingml/2006/main">
             <a:fillRect l="0" t="0" r="0" b="0"/>
@@ -1954,6 +1950,7 @@
           <a:lstStyle xmlns:a="http://schemas.openxmlformats.org/drawingml/2006/main"/>
           <a:p xmlns:a="http://schemas.openxmlformats.org/drawingml/2006/main">
             <a:pPr>
+              <a:buNone/>
               <a:defRPr sz="4950" b="1">
                 <a:solidFill>
                   <a:srgbClr val="102E36"/>
@@ -1977,6 +1974,7 @@
           </a:p>
           <a:p xmlns:a="http://schemas.openxmlformats.org/drawingml/2006/main">
             <a:pPr>
+              <a:buNone/>
               <a:defRPr sz="4950" b="1">
                 <a:solidFill>
                   <a:srgbClr val="102E36"/>
@@ -2034,6 +2032,7 @@
           <a:lstStyle xmlns:a="http://schemas.openxmlformats.org/drawingml/2006/main"/>
           <a:p xmlns:a="http://schemas.openxmlformats.org/drawingml/2006/main">
             <a:pPr>
+              <a:buNone/>
               <a:defRPr sz="2625" b="0">
                 <a:solidFill>
                   <a:srgbClr val="102E36"/>
@@ -2057,6 +2056,7 @@
           </a:p>
           <a:p xmlns:a="http://schemas.openxmlformats.org/drawingml/2006/main">
             <a:pPr>
+              <a:buNone/>
               <a:defRPr sz="2625" b="0">
                 <a:solidFill>
                   <a:srgbClr val="102E36"/>
@@ -2114,6 +2114,7 @@
           <a:lstStyle xmlns:a="http://schemas.openxmlformats.org/drawingml/2006/main"/>
           <a:p xmlns:a="http://schemas.openxmlformats.org/drawingml/2006/main">
             <a:pPr>
+              <a:buNone/>
               <a:defRPr sz="1800" b="0">
                 <a:solidFill>
                   <a:srgbClr val="48636A"/>
@@ -2137,6 +2138,7 @@
           </a:p>
           <a:p xmlns:a="http://schemas.openxmlformats.org/drawingml/2006/main">
             <a:pPr>
+              <a:buNone/>
               <a:defRPr sz="1800" b="0">
                 <a:solidFill>
                   <a:srgbClr val="48636A"/>
@@ -2223,6 +2225,7 @@
           <a:lstStyle xmlns:a="http://schemas.openxmlformats.org/drawingml/2006/main"/>
           <a:p xmlns:a="http://schemas.openxmlformats.org/drawingml/2006/main">
             <a:pPr>
+              <a:buNone/>
               <a:defRPr sz="3450" b="1">
                 <a:solidFill>
                   <a:srgbClr val="102E36"/>
@@ -2241,7 +2244,7 @@
                 <a:ea typeface="Aptos"/>
                 <a:cs typeface="Aptos"/>
               </a:rPr>
-              <a:t>The gene points to a cell-division problem</a:t>
+              <a:t>Protein supply is a testable mechanism</a:t>
             </a:r>
           </a:p>
         </p:txBody>
@@ -2280,6 +2283,7 @@
           <a:lstStyle xmlns:a="http://schemas.openxmlformats.org/drawingml/2006/main"/>
           <a:p xmlns:a="http://schemas.openxmlformats.org/drawingml/2006/main">
             <a:pPr>
+              <a:buNone/>
               <a:defRPr sz="1350" b="0">
                 <a:solidFill>
                   <a:srgbClr val="48636A"/>
@@ -2337,6 +2341,7 @@
           <a:lstStyle xmlns:a="http://schemas.openxmlformats.org/drawingml/2006/main"/>
           <a:p xmlns:a="http://schemas.openxmlformats.org/drawingml/2006/main">
             <a:pPr>
+              <a:buNone/>
               <a:defRPr sz="2325" b="0">
                 <a:solidFill>
                   <a:srgbClr val="102E36"/>
@@ -2355,14 +2360,14 @@
                 <a:ea typeface="Aptos"/>
                 <a:cs typeface="Aptos"/>
               </a:rPr>
-              <a:t>BUB1B is the gene. BUBR1 is the protein that helps cells divide accurately.</a:t>
+              <a:t>A stop plus a kinase-region missense change matches a reported MVA1 pattern.</a:t>
             </a:r>
           </a:p>
         </p:txBody>
       </p:sp>
       <p:graphicFrame>
         <p:nvGraphicFramePr>
-          <p:cNvPr id="9" name=""/>
+          <p:cNvPr id="11" name=""/>
           <p:cNvGraphicFramePr/>
           <p:nvPr/>
         </p:nvGraphicFramePr>
@@ -2529,7 +2534,7 @@
                           <a:ea typeface="Aptos"/>
                           <a:cs typeface="Aptos"/>
                         </a:rPr>
-                        <a:t>A protein change whose function remains uncertain</a:t>
+                        <a:t>Kinase-region change. Stability and function unmeasured</a:t>
                       </a:r>
                     </a:p>
                   </a:txBody>
@@ -2578,6 +2583,7 @@
           <a:lstStyle xmlns:a="http://schemas.openxmlformats.org/drawingml/2006/main"/>
           <a:p xmlns:a="http://schemas.openxmlformats.org/drawingml/2006/main">
             <a:pPr>
+              <a:buNone/>
               <a:defRPr sz="2025" b="1">
                 <a:solidFill>
                   <a:srgbClr val="167A78"/>
@@ -2596,11 +2602,12 @@
                 <a:ea typeface="Aptos"/>
                 <a:cs typeface="Aptos"/>
               </a:rPr>
-              <a:t>Confirmed cis [L737Ter;N1002K]/WT retires this</a:t>
+              <a:t>Trans remains unobserved. Confirmed cis retires this</a:t>
             </a:r>
           </a:p>
           <a:p xmlns:a="http://schemas.openxmlformats.org/drawingml/2006/main">
             <a:pPr>
+              <a:buNone/>
               <a:defRPr sz="2025" b="1">
                 <a:solidFill>
                   <a:srgbClr val="167A78"/>
@@ -2655,10 +2662,10 @@
       </p:grpSpPr>
       <p:sp>
         <p:nvSpPr>
-          <p:cNvPr id="10" name="">
+          <p:cNvPr id="6" name="">
             <a:extLst xmlns:a="http://schemas.openxmlformats.org/drawingml/2006/main">
               <a:ext uri="{FF2B5EF4-FFF2-40B4-BE49-F238E27FC236}">
-                <a16:creationId xmlns:a16="http://schemas.microsoft.com/office/drawing/2014/main" id="{8DEE6D5E-595D-4C3B-9829-4BFBA424E893}"/>
+                <a16:creationId xmlns:a16="http://schemas.microsoft.com/office/drawing/2014/main" id="{7DA0E73E-41D3-4099-9AA3-28EC736ADBF0}"/>
               </a:ext>
             </a:extLst>
           </p:cNvPr>
@@ -2687,6 +2694,7 @@
           <a:lstStyle xmlns:a="http://schemas.openxmlformats.org/drawingml/2006/main"/>
           <a:p xmlns:a="http://schemas.openxmlformats.org/drawingml/2006/main">
             <a:pPr>
+              <a:buNone/>
               <a:defRPr sz="3450" b="1">
                 <a:solidFill>
                   <a:srgbClr val="102E36"/>
@@ -2705,7 +2713,7 @@
                 <a:ea typeface="Aptos"/>
                 <a:cs typeface="Aptos"/>
               </a:rPr>
-              <a:t>Everolimus tests excess growth signaling</a:t>
+              <a:t>Niacin tests usable protein restoration</a:t>
             </a:r>
           </a:p>
         </p:txBody>
@@ -2715,7 +2723,7 @@
           <p:cNvPr id="2" name="">
             <a:extLst xmlns:a="http://schemas.openxmlformats.org/drawingml/2006/main">
               <a:ext uri="{FF2B5EF4-FFF2-40B4-BE49-F238E27FC236}">
-                <a16:creationId xmlns:a16="http://schemas.microsoft.com/office/drawing/2014/main" id="{75610479-4D6B-4AD8-B5BC-6DE7869B5935}"/>
+                <a16:creationId xmlns:a16="http://schemas.microsoft.com/office/drawing/2014/main" id="{580E203D-117B-4514-A8D8-06ADAE25428D}"/>
               </a:ext>
             </a:extLst>
           </p:cNvPr>
@@ -2744,6 +2752,7 @@
           <a:lstStyle xmlns:a="http://schemas.openxmlformats.org/drawingml/2006/main"/>
           <a:p xmlns:a="http://schemas.openxmlformats.org/drawingml/2006/main">
             <a:pPr>
+              <a:buNone/>
               <a:defRPr sz="1350" b="0">
                 <a:solidFill>
                   <a:srgbClr val="48636A"/>
@@ -2763,594 +2772,6 @@
                 <a:cs typeface="Aptos"/>
               </a:rPr>
               <a:t>3 / 8</a:t>
-            </a:r>
-          </a:p>
-        </p:txBody>
-      </p:sp>
-      <p:sp>
-        <p:nvSpPr>
-          <p:cNvPr id="3" name="">
-            <a:extLst xmlns:a="http://schemas.openxmlformats.org/drawingml/2006/main">
-              <a:ext uri="{FF2B5EF4-FFF2-40B4-BE49-F238E27FC236}">
-                <a16:creationId xmlns:a16="http://schemas.microsoft.com/office/drawing/2014/main" id="{AE2F4C86-A8A0-4EE9-BF6A-CE7D269C0CF5}"/>
-              </a:ext>
-            </a:extLst>
-          </p:cNvPr>
-          <p:cNvSpPr>
-            <a:spLocks xmlns:a="http://schemas.openxmlformats.org/drawingml/2006/main" noGrp="1"/>
-          </p:cNvSpPr>
-          <p:nvPr/>
-        </p:nvSpPr>
-        <p:spPr>
-          <a:xfrm xmlns:a="http://schemas.openxmlformats.org/drawingml/2006/main">
-            <a:off x="685800" y="1905000"/>
-            <a:ext cx="4762500" cy="857250"/>
-          </a:xfrm>
-          <a:prstGeom xmlns:a="http://schemas.openxmlformats.org/drawingml/2006/main" prst="rect">
-            <a:avLst/>
-          </a:prstGeom>
-          <a:noFill xmlns:a="http://schemas.openxmlformats.org/drawingml/2006/main"/>
-          <a:ln xmlns:a="http://schemas.openxmlformats.org/drawingml/2006/main" w="0">
-            <a:noFill/>
-          </a:ln>
-        </p:spPr>
-        <p:txBody>
-          <a:bodyPr xmlns:a="http://schemas.openxmlformats.org/drawingml/2006/main" anchor="ctr">
-            <a:noAutofit/>
-          </a:bodyPr>
-          <a:lstStyle xmlns:a="http://schemas.openxmlformats.org/drawingml/2006/main"/>
-          <a:p xmlns:a="http://schemas.openxmlformats.org/drawingml/2006/main">
-            <a:pPr>
-              <a:defRPr sz="5400" b="1">
-                <a:solidFill>
-                  <a:srgbClr val="167A78"/>
-                </a:solidFill>
-                <a:latin typeface="Aptos"/>
-                <a:ea typeface="Aptos"/>
-                <a:cs typeface="Aptos"/>
-              </a:defRPr>
-            </a:pPr>
-            <a:r>
-              <a:rPr sz="5400" b="1">
-                <a:solidFill>
-                  <a:srgbClr val="167A78"/>
-                </a:solidFill>
-                <a:latin typeface="Aptos"/>
-                <a:ea typeface="Aptos"/>
-                <a:cs typeface="Aptos"/>
-              </a:rPr>
-              <a:t>mTORC1</a:t>
-            </a:r>
-          </a:p>
-        </p:txBody>
-      </p:sp>
-      <p:sp>
-        <p:nvSpPr>
-          <p:cNvPr id="4" name="">
-            <a:extLst xmlns:a="http://schemas.openxmlformats.org/drawingml/2006/main">
-              <a:ext uri="{FF2B5EF4-FFF2-40B4-BE49-F238E27FC236}">
-                <a16:creationId xmlns:a16="http://schemas.microsoft.com/office/drawing/2014/main" id="{10CD5A01-4553-4751-B921-AD1CB456D429}"/>
-              </a:ext>
-            </a:extLst>
-          </p:cNvPr>
-          <p:cNvSpPr>
-            <a:spLocks xmlns:a="http://schemas.openxmlformats.org/drawingml/2006/main" noGrp="1"/>
-          </p:cNvSpPr>
-          <p:nvPr/>
-        </p:nvSpPr>
-        <p:spPr>
-          <a:xfrm xmlns:a="http://schemas.openxmlformats.org/drawingml/2006/main">
-            <a:off x="723900" y="2857500"/>
-            <a:ext cx="4667250" cy="1028700"/>
-          </a:xfrm>
-          <a:prstGeom xmlns:a="http://schemas.openxmlformats.org/drawingml/2006/main" prst="rect">
-            <a:avLst/>
-          </a:prstGeom>
-          <a:noFill xmlns:a="http://schemas.openxmlformats.org/drawingml/2006/main"/>
-          <a:ln xmlns:a="http://schemas.openxmlformats.org/drawingml/2006/main" w="0">
-            <a:noFill/>
-          </a:ln>
-        </p:spPr>
-        <p:txBody>
-          <a:bodyPr xmlns:a="http://schemas.openxmlformats.org/drawingml/2006/main" anchor="ctr">
-            <a:noAutofit/>
-          </a:bodyPr>
-          <a:lstStyle xmlns:a="http://schemas.openxmlformats.org/drawingml/2006/main"/>
-          <a:p xmlns:a="http://schemas.openxmlformats.org/drawingml/2006/main">
-            <a:pPr>
-              <a:defRPr sz="2475" b="0">
-                <a:solidFill>
-                  <a:srgbClr val="102E36"/>
-                </a:solidFill>
-                <a:latin typeface="Aptos"/>
-                <a:ea typeface="Aptos"/>
-                <a:cs typeface="Aptos"/>
-              </a:defRPr>
-            </a:pPr>
-            <a:r>
-              <a:rPr sz="2475" b="0">
-                <a:solidFill>
-                  <a:srgbClr val="102E36"/>
-                </a:solidFill>
-                <a:latin typeface="Aptos"/>
-                <a:ea typeface="Aptos"/>
-                <a:cs typeface="Aptos"/>
-              </a:rPr>
-              <a:t>A pathway that regulates cell growth</a:t>
-            </a:r>
-          </a:p>
-        </p:txBody>
-      </p:sp>
-      <p:sp>
-        <p:nvSpPr>
-          <p:cNvPr id="5" name="">
-            <a:extLst xmlns:a="http://schemas.openxmlformats.org/drawingml/2006/main">
-              <a:ext uri="{FF2B5EF4-FFF2-40B4-BE49-F238E27FC236}">
-                <a16:creationId xmlns:a16="http://schemas.microsoft.com/office/drawing/2014/main" id="{525D8CBD-3710-465A-A024-C7DF5F5424C4}"/>
-              </a:ext>
-            </a:extLst>
-          </p:cNvPr>
-          <p:cNvSpPr>
-            <a:spLocks xmlns:a="http://schemas.openxmlformats.org/drawingml/2006/main" noGrp="1"/>
-          </p:cNvSpPr>
-          <p:nvPr/>
-        </p:nvSpPr>
-        <p:spPr>
-          <a:xfrm xmlns:a="http://schemas.openxmlformats.org/drawingml/2006/main">
-            <a:off x="6286500" y="1828800"/>
-            <a:ext cx="4953000" cy="457200"/>
-          </a:xfrm>
-          <a:prstGeom xmlns:a="http://schemas.openxmlformats.org/drawingml/2006/main" prst="rect">
-            <a:avLst/>
-          </a:prstGeom>
-          <a:noFill xmlns:a="http://schemas.openxmlformats.org/drawingml/2006/main"/>
-          <a:ln xmlns:a="http://schemas.openxmlformats.org/drawingml/2006/main" w="0">
-            <a:noFill/>
-          </a:ln>
-        </p:spPr>
-        <p:txBody>
-          <a:bodyPr xmlns:a="http://schemas.openxmlformats.org/drawingml/2006/main" anchor="ctr">
-            <a:noAutofit/>
-          </a:bodyPr>
-          <a:lstStyle xmlns:a="http://schemas.openxmlformats.org/drawingml/2006/main"/>
-          <a:p xmlns:a="http://schemas.openxmlformats.org/drawingml/2006/main">
-            <a:pPr>
-              <a:defRPr sz="2025" b="1">
-                <a:solidFill>
-                  <a:srgbClr val="167A78"/>
-                </a:solidFill>
-                <a:latin typeface="Aptos"/>
-                <a:ea typeface="Aptos"/>
-                <a:cs typeface="Aptos"/>
-              </a:defRPr>
-            </a:pPr>
-            <a:r>
-              <a:rPr sz="2025" b="1">
-                <a:solidFill>
-                  <a:srgbClr val="167A78"/>
-                </a:solidFill>
-                <a:latin typeface="Aptos"/>
-                <a:ea typeface="Aptos"/>
-                <a:cs typeface="Aptos"/>
-              </a:rPr>
-              <a:t>Evidence</a:t>
-            </a:r>
-          </a:p>
-        </p:txBody>
-      </p:sp>
-      <p:sp>
-        <p:nvSpPr>
-          <p:cNvPr id="6" name="">
-            <a:extLst xmlns:a="http://schemas.openxmlformats.org/drawingml/2006/main">
-              <a:ext uri="{FF2B5EF4-FFF2-40B4-BE49-F238E27FC236}">
-                <a16:creationId xmlns:a16="http://schemas.microsoft.com/office/drawing/2014/main" id="{6B65E5EB-60B3-4D4E-A857-083847F15C47}"/>
-              </a:ext>
-            </a:extLst>
-          </p:cNvPr>
-          <p:cNvSpPr>
-            <a:spLocks xmlns:a="http://schemas.openxmlformats.org/drawingml/2006/main" noGrp="1"/>
-          </p:cNvSpPr>
-          <p:nvPr/>
-        </p:nvSpPr>
-        <p:spPr>
-          <a:xfrm xmlns:a="http://schemas.openxmlformats.org/drawingml/2006/main">
-            <a:off x="6286500" y="2314575"/>
-            <a:ext cx="5048250" cy="1600200"/>
-          </a:xfrm>
-          <a:prstGeom xmlns:a="http://schemas.openxmlformats.org/drawingml/2006/main" prst="rect">
-            <a:avLst/>
-          </a:prstGeom>
-          <a:noFill xmlns:a="http://schemas.openxmlformats.org/drawingml/2006/main"/>
-          <a:ln xmlns:a="http://schemas.openxmlformats.org/drawingml/2006/main" w="0">
-            <a:noFill/>
-          </a:ln>
-        </p:spPr>
-        <p:txBody>
-          <a:bodyPr xmlns:a="http://schemas.openxmlformats.org/drawingml/2006/main" anchor="ctr">
-            <a:noAutofit/>
-          </a:bodyPr>
-          <a:lstStyle xmlns:a="http://schemas.openxmlformats.org/drawingml/2006/main"/>
-          <a:p xmlns:a="http://schemas.openxmlformats.org/drawingml/2006/main">
-            <a:pPr>
-              <a:defRPr sz="2250" b="0">
-                <a:solidFill>
-                  <a:srgbClr val="102E36"/>
-                </a:solidFill>
-                <a:latin typeface="Aptos"/>
-                <a:ea typeface="Aptos"/>
-                <a:cs typeface="Aptos"/>
-              </a:defRPr>
-            </a:pPr>
-            <a:r>
-              <a:rPr sz="2250" b="0">
-                <a:solidFill>
-                  <a:srgbClr val="102E36"/>
-                </a:solidFill>
-                <a:latin typeface="Aptos"/>
-                <a:ea typeface="Aptos"/>
-                <a:cs typeface="Aptos"/>
-              </a:rPr>
-              <a:t>Visually stronger pS6K / p4EBP1 bands</a:t>
-            </a:r>
-          </a:p>
-          <a:p xmlns:a="http://schemas.openxmlformats.org/drawingml/2006/main">
-            <a:pPr>
-              <a:defRPr sz="2250" b="0">
-                <a:solidFill>
-                  <a:srgbClr val="102E36"/>
-                </a:solidFill>
-                <a:latin typeface="Aptos"/>
-                <a:ea typeface="Aptos"/>
-                <a:cs typeface="Aptos"/>
-              </a:defRPr>
-            </a:pPr>
-            <a:r>
-              <a:rPr sz="2250" b="0">
-                <a:solidFill>
-                  <a:srgbClr val="102E36"/>
-                </a:solidFill>
-                <a:latin typeface="Aptos"/>
-                <a:ea typeface="Aptos"/>
-                <a:cs typeface="Aptos"/>
-              </a:rPr>
-              <a:t>BubR1+/X753 versus WT</a:t>
-            </a:r>
-          </a:p>
-          <a:p xmlns:a="http://schemas.openxmlformats.org/drawingml/2006/main">
-            <a:pPr>
-              <a:defRPr sz="2250" b="0">
-                <a:solidFill>
-                  <a:srgbClr val="102E36"/>
-                </a:solidFill>
-                <a:latin typeface="Aptos"/>
-                <a:ea typeface="Aptos"/>
-                <a:cs typeface="Aptos"/>
-              </a:defRPr>
-            </a:pPr>
-            <a:r>
-              <a:rPr sz="2250" b="0">
-                <a:solidFill>
-                  <a:srgbClr val="102E36"/>
-                </a:solidFill>
-                <a:latin typeface="Aptos"/>
-                <a:ea typeface="Aptos"/>
-                <a:cs typeface="Aptos"/>
-              </a:rPr>
-              <a:t>Two mice per genotype</a:t>
-            </a:r>
-          </a:p>
-        </p:txBody>
-      </p:sp>
-      <p:sp>
-        <p:nvSpPr>
-          <p:cNvPr id="7" name="">
-            <a:extLst xmlns:a="http://schemas.openxmlformats.org/drawingml/2006/main">
-              <a:ext uri="{FF2B5EF4-FFF2-40B4-BE49-F238E27FC236}">
-                <a16:creationId xmlns:a16="http://schemas.microsoft.com/office/drawing/2014/main" id="{C6AAF6BA-2CB7-4692-A1EE-56D61490A9EC}"/>
-              </a:ext>
-            </a:extLst>
-          </p:cNvPr>
-          <p:cNvSpPr>
-            <a:spLocks xmlns:a="http://schemas.openxmlformats.org/drawingml/2006/main" noGrp="1"/>
-          </p:cNvSpPr>
-          <p:nvPr/>
-        </p:nvSpPr>
-        <p:spPr>
-          <a:xfrm xmlns:a="http://schemas.openxmlformats.org/drawingml/2006/main">
-            <a:off x="6286500" y="4000500"/>
-            <a:ext cx="4762500" cy="457200"/>
-          </a:xfrm>
-          <a:prstGeom xmlns:a="http://schemas.openxmlformats.org/drawingml/2006/main" prst="rect">
-            <a:avLst/>
-          </a:prstGeom>
-          <a:noFill xmlns:a="http://schemas.openxmlformats.org/drawingml/2006/main"/>
-          <a:ln xmlns:a="http://schemas.openxmlformats.org/drawingml/2006/main" w="0">
-            <a:noFill/>
-          </a:ln>
-        </p:spPr>
-        <p:txBody>
-          <a:bodyPr xmlns:a="http://schemas.openxmlformats.org/drawingml/2006/main" anchor="ctr">
-            <a:noAutofit/>
-          </a:bodyPr>
-          <a:lstStyle xmlns:a="http://schemas.openxmlformats.org/drawingml/2006/main"/>
-          <a:p xmlns:a="http://schemas.openxmlformats.org/drawingml/2006/main">
-            <a:pPr>
-              <a:defRPr sz="2025" b="1">
-                <a:solidFill>
-                  <a:srgbClr val="B07827"/>
-                </a:solidFill>
-                <a:latin typeface="Aptos"/>
-                <a:ea typeface="Aptos"/>
-                <a:cs typeface="Aptos"/>
-              </a:defRPr>
-            </a:pPr>
-            <a:r>
-              <a:rPr sz="2025" b="1">
-                <a:solidFill>
-                  <a:srgbClr val="B07827"/>
-                </a:solidFill>
-                <a:latin typeface="Aptos"/>
-                <a:ea typeface="Aptos"/>
-                <a:cs typeface="Aptos"/>
-              </a:rPr>
-              <a:t>Missing</a:t>
-            </a:r>
-          </a:p>
-        </p:txBody>
-      </p:sp>
-      <p:sp>
-        <p:nvSpPr>
-          <p:cNvPr id="8" name="">
-            <a:extLst xmlns:a="http://schemas.openxmlformats.org/drawingml/2006/main">
-              <a:ext uri="{FF2B5EF4-FFF2-40B4-BE49-F238E27FC236}">
-                <a16:creationId xmlns:a16="http://schemas.microsoft.com/office/drawing/2014/main" id="{9D180964-4EDC-40BB-89BA-11A5EB08A0CA}"/>
-              </a:ext>
-            </a:extLst>
-          </p:cNvPr>
-          <p:cNvSpPr>
-            <a:spLocks xmlns:a="http://schemas.openxmlformats.org/drawingml/2006/main" noGrp="1"/>
-          </p:cNvSpPr>
-          <p:nvPr/>
-        </p:nvSpPr>
-        <p:spPr>
-          <a:xfrm xmlns:a="http://schemas.openxmlformats.org/drawingml/2006/main">
-            <a:off x="6286500" y="4486275"/>
-            <a:ext cx="5048250" cy="1333500"/>
-          </a:xfrm>
-          <a:prstGeom xmlns:a="http://schemas.openxmlformats.org/drawingml/2006/main" prst="rect">
-            <a:avLst/>
-          </a:prstGeom>
-          <a:noFill xmlns:a="http://schemas.openxmlformats.org/drawingml/2006/main"/>
-          <a:ln xmlns:a="http://schemas.openxmlformats.org/drawingml/2006/main" w="0">
-            <a:noFill/>
-          </a:ln>
-        </p:spPr>
-        <p:txBody>
-          <a:bodyPr xmlns:a="http://schemas.openxmlformats.org/drawingml/2006/main" anchor="ctr">
-            <a:noAutofit/>
-          </a:bodyPr>
-          <a:lstStyle xmlns:a="http://schemas.openxmlformats.org/drawingml/2006/main"/>
-          <a:p xmlns:a="http://schemas.openxmlformats.org/drawingml/2006/main">
-            <a:pPr>
-              <a:defRPr sz="2250" b="0">
-                <a:solidFill>
-                  <a:srgbClr val="102E36"/>
-                </a:solidFill>
-                <a:latin typeface="Aptos"/>
-                <a:ea typeface="Aptos"/>
-                <a:cs typeface="Aptos"/>
-              </a:defRPr>
-            </a:pPr>
-            <a:r>
-              <a:rPr sz="2250" b="0">
-                <a:solidFill>
-                  <a:srgbClr val="102E36"/>
-                </a:solidFill>
-                <a:latin typeface="Aptos"/>
-                <a:ea typeface="Aptos"/>
-                <a:cs typeface="Aptos"/>
-              </a:rPr>
-              <a:t>Pathway hyperactivity, harmful excess and useful muscle benefit remain unproved</a:t>
-            </a:r>
-          </a:p>
-        </p:txBody>
-      </p:sp>
-      <p:sp>
-        <p:nvSpPr>
-          <p:cNvPr id="9" name="">
-            <a:extLst xmlns:a="http://schemas.openxmlformats.org/drawingml/2006/main">
-              <a:ext uri="{FF2B5EF4-FFF2-40B4-BE49-F238E27FC236}">
-                <a16:creationId xmlns:a16="http://schemas.microsoft.com/office/drawing/2014/main" id="{02678E2D-02C6-4C36-8167-03523F2B3B6C}"/>
-              </a:ext>
-            </a:extLst>
-          </p:cNvPr>
-          <p:cNvSpPr>
-            <a:spLocks xmlns:a="http://schemas.openxmlformats.org/drawingml/2006/main" noGrp="1"/>
-          </p:cNvSpPr>
-          <p:nvPr/>
-        </p:nvSpPr>
-        <p:spPr>
-          <a:xfrm xmlns:a="http://schemas.openxmlformats.org/drawingml/2006/main">
-            <a:off x="685800" y="6067425"/>
-            <a:ext cx="10572750" cy="400050"/>
-          </a:xfrm>
-          <a:prstGeom xmlns:a="http://schemas.openxmlformats.org/drawingml/2006/main" prst="rect">
-            <a:avLst/>
-          </a:prstGeom>
-          <a:noFill xmlns:a="http://schemas.openxmlformats.org/drawingml/2006/main"/>
-          <a:ln xmlns:a="http://schemas.openxmlformats.org/drawingml/2006/main" w="0">
-            <a:noFill/>
-          </a:ln>
-        </p:spPr>
-        <p:txBody>
-          <a:bodyPr xmlns:a="http://schemas.openxmlformats.org/drawingml/2006/main" anchor="ctr">
-            <a:noAutofit/>
-          </a:bodyPr>
-          <a:lstStyle xmlns:a="http://schemas.openxmlformats.org/drawingml/2006/main"/>
-          <a:p xmlns:a="http://schemas.openxmlformats.org/drawingml/2006/main">
-            <a:pPr>
-              <a:defRPr sz="1650" b="0">
-                <a:solidFill>
-                  <a:srgbClr val="48636A"/>
-                </a:solidFill>
-                <a:latin typeface="Aptos"/>
-                <a:ea typeface="Aptos"/>
-                <a:cs typeface="Aptos"/>
-              </a:defRPr>
-            </a:pPr>
-            <a:r>
-              <a:rPr sz="1650" b="0">
-                <a:solidFill>
-                  <a:srgbClr val="48636A"/>
-                </a:solidFill>
-                <a:latin typeface="Aptos"/>
-                <a:ea typeface="Aptos"/>
-                <a:cs typeface="Aptos"/>
-              </a:rPr>
-              <a:t>No phospho/total ratios, quantification or statistical tests. No drug rescue.</a:t>
-            </a:r>
-          </a:p>
-        </p:txBody>
-      </p:sp>
-    </p:spTree>
-    <p:extLst>
-      <p:ext uri="{BB962C8B-B14F-4D97-AF65-F5344CB8AC3E}">
-        <p14:creationId xmlns:p14="http://schemas.microsoft.com/office/powerpoint/2010/main" val="2020503096"/>
-      </p:ext>
-    </p:extLst>
-  </p:cSld>
-</p:sld>
-</file>
-
-<file path=ppt/slides/slide4.xml><?xml version="1.0" encoding="utf-8"?>
-<p:sld xmlns:p="http://schemas.openxmlformats.org/presentationml/2006/main">
-  <p:cSld>
-    <p:bg>
-      <p:bgPr>
-        <a:solidFill xmlns:a="http://schemas.openxmlformats.org/drawingml/2006/main">
-          <a:srgbClr val="F6F3EC"/>
-        </a:solidFill>
-      </p:bgPr>
-    </p:bg>
-    <p:spTree>
-      <p:nvGrpSpPr>
-        <p:cNvPr id="1" name=""/>
-        <p:cNvGrpSpPr/>
-        <p:nvPr/>
-      </p:nvGrpSpPr>
-      <p:grpSpPr>
-        <a:xfrm xmlns:a="http://schemas.openxmlformats.org/drawingml/2006/main"/>
-      </p:grpSpPr>
-      <p:sp>
-        <p:nvSpPr>
-          <p:cNvPr id="6" name="">
-            <a:extLst xmlns:a="http://schemas.openxmlformats.org/drawingml/2006/main">
-              <a:ext uri="{FF2B5EF4-FFF2-40B4-BE49-F238E27FC236}">
-                <a16:creationId xmlns:a16="http://schemas.microsoft.com/office/drawing/2014/main" id="{7DA0E73E-41D3-4099-9AA3-28EC736ADBF0}"/>
-              </a:ext>
-            </a:extLst>
-          </p:cNvPr>
-          <p:cNvSpPr>
-            <a:spLocks xmlns:a="http://schemas.openxmlformats.org/drawingml/2006/main" noGrp="1"/>
-          </p:cNvSpPr>
-          <p:nvPr/>
-        </p:nvSpPr>
-        <p:spPr>
-          <a:xfrm xmlns:a="http://schemas.openxmlformats.org/drawingml/2006/main">
-            <a:off x="685800" y="457200"/>
-            <a:ext cx="10820400" cy="1028700"/>
-          </a:xfrm>
-          <a:prstGeom xmlns:a="http://schemas.openxmlformats.org/drawingml/2006/main" prst="rect">
-            <a:avLst/>
-          </a:prstGeom>
-          <a:noFill xmlns:a="http://schemas.openxmlformats.org/drawingml/2006/main"/>
-          <a:ln xmlns:a="http://schemas.openxmlformats.org/drawingml/2006/main" w="0">
-            <a:noFill/>
-          </a:ln>
-        </p:spPr>
-        <p:txBody>
-          <a:bodyPr xmlns:a="http://schemas.openxmlformats.org/drawingml/2006/main" anchor="ctr">
-            <a:noAutofit/>
-          </a:bodyPr>
-          <a:lstStyle xmlns:a="http://schemas.openxmlformats.org/drawingml/2006/main"/>
-          <a:p xmlns:a="http://schemas.openxmlformats.org/drawingml/2006/main">
-            <a:pPr>
-              <a:defRPr sz="3450" b="1">
-                <a:solidFill>
-                  <a:srgbClr val="102E36"/>
-                </a:solidFill>
-                <a:latin typeface="Aptos"/>
-                <a:ea typeface="Aptos"/>
-                <a:cs typeface="Aptos"/>
-              </a:defRPr>
-            </a:pPr>
-            <a:r>
-              <a:rPr sz="3450" b="1">
-                <a:solidFill>
-                  <a:srgbClr val="102E36"/>
-                </a:solidFill>
-                <a:latin typeface="Aptos"/>
-                <a:ea typeface="Aptos"/>
-                <a:cs typeface="Aptos"/>
-              </a:rPr>
-              <a:t>Niacin tests usable protein restoration</a:t>
-            </a:r>
-          </a:p>
-        </p:txBody>
-      </p:sp>
-      <p:sp>
-        <p:nvSpPr>
-          <p:cNvPr id="2" name="">
-            <a:extLst xmlns:a="http://schemas.openxmlformats.org/drawingml/2006/main">
-              <a:ext uri="{FF2B5EF4-FFF2-40B4-BE49-F238E27FC236}">
-                <a16:creationId xmlns:a16="http://schemas.microsoft.com/office/drawing/2014/main" id="{580E203D-117B-4514-A8D8-06ADAE25428D}"/>
-              </a:ext>
-            </a:extLst>
-          </p:cNvPr>
-          <p:cNvSpPr>
-            <a:spLocks xmlns:a="http://schemas.openxmlformats.org/drawingml/2006/main" noGrp="1"/>
-          </p:cNvSpPr>
-          <p:nvPr/>
-        </p:nvSpPr>
-        <p:spPr>
-          <a:xfrm xmlns:a="http://schemas.openxmlformats.org/drawingml/2006/main">
-            <a:off x="10801350" y="6305550"/>
-            <a:ext cx="704850" cy="266700"/>
-          </a:xfrm>
-          <a:prstGeom xmlns:a="http://schemas.openxmlformats.org/drawingml/2006/main" prst="rect">
-            <a:avLst/>
-          </a:prstGeom>
-          <a:noFill xmlns:a="http://schemas.openxmlformats.org/drawingml/2006/main"/>
-          <a:ln xmlns:a="http://schemas.openxmlformats.org/drawingml/2006/main" w="0">
-            <a:noFill/>
-          </a:ln>
-        </p:spPr>
-        <p:txBody>
-          <a:bodyPr xmlns:a="http://schemas.openxmlformats.org/drawingml/2006/main" anchor="ctr">
-            <a:noAutofit/>
-          </a:bodyPr>
-          <a:lstStyle xmlns:a="http://schemas.openxmlformats.org/drawingml/2006/main"/>
-          <a:p xmlns:a="http://schemas.openxmlformats.org/drawingml/2006/main">
-            <a:pPr>
-              <a:defRPr sz="1350" b="0">
-                <a:solidFill>
-                  <a:srgbClr val="48636A"/>
-                </a:solidFill>
-                <a:latin typeface="Aptos"/>
-                <a:ea typeface="Aptos"/>
-                <a:cs typeface="Aptos"/>
-              </a:defRPr>
-            </a:pPr>
-            <a:r>
-              <a:rPr sz="1350" b="0">
-                <a:solidFill>
-                  <a:srgbClr val="48636A"/>
-                </a:solidFill>
-                <a:latin typeface="Aptos"/>
-                <a:ea typeface="Aptos"/>
-                <a:cs typeface="Aptos"/>
-              </a:rPr>
-              <a:t>4 / 8</a:t>
             </a:r>
           </a:p>
         </p:txBody>
@@ -3389,6 +2810,7 @@
           <a:lstStyle xmlns:a="http://schemas.openxmlformats.org/drawingml/2006/main"/>
           <a:p xmlns:a="http://schemas.openxmlformats.org/drawingml/2006/main">
             <a:pPr>
+              <a:buNone/>
               <a:defRPr sz="3225" b="1">
                 <a:solidFill>
                   <a:srgbClr val="167A78"/>
@@ -3407,14 +2829,14 @@
                 <a:ea typeface="Aptos"/>
                 <a:cs typeface="Aptos"/>
               </a:rPr>
-              <a:t>Niacin = nicotinic acid</a:t>
+              <a:t>Research lead: nicotinic acid</a:t>
             </a:r>
           </a:p>
         </p:txBody>
       </p:sp>
       <p:graphicFrame>
         <p:nvGraphicFramePr>
-          <p:cNvPr id="9" name=""/>
+          <p:cNvPr id="11" name=""/>
           <p:cNvGraphicFramePr/>
           <p:nvPr/>
         </p:nvGraphicFramePr>
@@ -3684,6 +3106,7 @@
           <a:lstStyle xmlns:a="http://schemas.openxmlformats.org/drawingml/2006/main"/>
           <a:p xmlns:a="http://schemas.openxmlformats.org/drawingml/2006/main">
             <a:pPr>
+              <a:buNone/>
               <a:defRPr sz="1725" b="0">
                 <a:solidFill>
                   <a:srgbClr val="48636A"/>
@@ -3702,7 +3125,7 @@
                 <a:ea typeface="Aptos"/>
                 <a:cs typeface="Aptos"/>
               </a:rPr>
-              <a:t>NAD supports cell chemistry. SIRT2 is an enzyme. Neither is proof of rescue.</a:t>
+              <a:t>Strength gains also occurred in treated controls. MVA rescue remains untested.</a:t>
             </a:r>
           </a:p>
         </p:txBody>
@@ -3711,6 +3134,605 @@
     <p:extLst>
       <p:ext uri="{BB962C8B-B14F-4D97-AF65-F5344CB8AC3E}">
         <p14:creationId xmlns:p14="http://schemas.microsoft.com/office/powerpoint/2010/main" val="1345422072"/>
+      </p:ext>
+    </p:extLst>
+  </p:cSld>
+</p:sld>
+</file>
+
+<file path=ppt/slides/slide4.xml><?xml version="1.0" encoding="utf-8"?>
+<p:sld xmlns:p="http://schemas.openxmlformats.org/presentationml/2006/main">
+  <p:cSld>
+    <p:bg>
+      <p:bgPr>
+        <a:solidFill xmlns:a="http://schemas.openxmlformats.org/drawingml/2006/main">
+          <a:srgbClr val="F6F3EC"/>
+        </a:solidFill>
+      </p:bgPr>
+    </p:bg>
+    <p:spTree>
+      <p:nvGrpSpPr>
+        <p:cNvPr id="1" name=""/>
+        <p:cNvGrpSpPr/>
+        <p:nvPr/>
+      </p:nvGrpSpPr>
+      <p:grpSpPr>
+        <a:xfrm xmlns:a="http://schemas.openxmlformats.org/drawingml/2006/main"/>
+      </p:grpSpPr>
+      <p:sp>
+        <p:nvSpPr>
+          <p:cNvPr id="10" name="">
+            <a:extLst xmlns:a="http://schemas.openxmlformats.org/drawingml/2006/main">
+              <a:ext uri="{FF2B5EF4-FFF2-40B4-BE49-F238E27FC236}">
+                <a16:creationId xmlns:a16="http://schemas.microsoft.com/office/drawing/2014/main" id="{8DEE6D5E-595D-4C3B-9829-4BFBA424E893}"/>
+              </a:ext>
+            </a:extLst>
+          </p:cNvPr>
+          <p:cNvSpPr>
+            <a:spLocks xmlns:a="http://schemas.openxmlformats.org/drawingml/2006/main" noGrp="1"/>
+          </p:cNvSpPr>
+          <p:nvPr/>
+        </p:nvSpPr>
+        <p:spPr>
+          <a:xfrm xmlns:a="http://schemas.openxmlformats.org/drawingml/2006/main">
+            <a:off x="685800" y="457200"/>
+            <a:ext cx="10820400" cy="1028700"/>
+          </a:xfrm>
+          <a:prstGeom xmlns:a="http://schemas.openxmlformats.org/drawingml/2006/main" prst="rect">
+            <a:avLst/>
+          </a:prstGeom>
+          <a:noFill xmlns:a="http://schemas.openxmlformats.org/drawingml/2006/main"/>
+          <a:ln xmlns:a="http://schemas.openxmlformats.org/drawingml/2006/main" w="0">
+            <a:noFill/>
+          </a:ln>
+        </p:spPr>
+        <p:txBody>
+          <a:bodyPr xmlns:a="http://schemas.openxmlformats.org/drawingml/2006/main" anchor="ctr">
+            <a:noAutofit/>
+          </a:bodyPr>
+          <a:lstStyle xmlns:a="http://schemas.openxmlformats.org/drawingml/2006/main"/>
+          <a:p xmlns:a="http://schemas.openxmlformats.org/drawingml/2006/main">
+            <a:pPr>
+              <a:buNone/>
+              <a:defRPr sz="3450" b="1">
+                <a:solidFill>
+                  <a:srgbClr val="102E36"/>
+                </a:solidFill>
+                <a:latin typeface="Aptos"/>
+                <a:ea typeface="Aptos"/>
+                <a:cs typeface="Aptos"/>
+              </a:defRPr>
+            </a:pPr>
+            <a:r>
+              <a:rPr sz="3450" b="1">
+                <a:solidFill>
+                  <a:srgbClr val="102E36"/>
+                </a:solidFill>
+                <a:latin typeface="Aptos"/>
+                <a:ea typeface="Aptos"/>
+                <a:cs typeface="Aptos"/>
+              </a:rPr>
+              <a:t>Everolimus is a downstream probe</a:t>
+            </a:r>
+          </a:p>
+        </p:txBody>
+      </p:sp>
+      <p:sp>
+        <p:nvSpPr>
+          <p:cNvPr id="2" name="">
+            <a:extLst xmlns:a="http://schemas.openxmlformats.org/drawingml/2006/main">
+              <a:ext uri="{FF2B5EF4-FFF2-40B4-BE49-F238E27FC236}">
+                <a16:creationId xmlns:a16="http://schemas.microsoft.com/office/drawing/2014/main" id="{75610479-4D6B-4AD8-B5BC-6DE7869B5935}"/>
+              </a:ext>
+            </a:extLst>
+          </p:cNvPr>
+          <p:cNvSpPr>
+            <a:spLocks xmlns:a="http://schemas.openxmlformats.org/drawingml/2006/main" noGrp="1"/>
+          </p:cNvSpPr>
+          <p:nvPr/>
+        </p:nvSpPr>
+        <p:spPr>
+          <a:xfrm xmlns:a="http://schemas.openxmlformats.org/drawingml/2006/main">
+            <a:off x="10801350" y="6305550"/>
+            <a:ext cx="704850" cy="266700"/>
+          </a:xfrm>
+          <a:prstGeom xmlns:a="http://schemas.openxmlformats.org/drawingml/2006/main" prst="rect">
+            <a:avLst/>
+          </a:prstGeom>
+          <a:noFill xmlns:a="http://schemas.openxmlformats.org/drawingml/2006/main"/>
+          <a:ln xmlns:a="http://schemas.openxmlformats.org/drawingml/2006/main" w="0">
+            <a:noFill/>
+          </a:ln>
+        </p:spPr>
+        <p:txBody>
+          <a:bodyPr xmlns:a="http://schemas.openxmlformats.org/drawingml/2006/main" anchor="ctr">
+            <a:noAutofit/>
+          </a:bodyPr>
+          <a:lstStyle xmlns:a="http://schemas.openxmlformats.org/drawingml/2006/main"/>
+          <a:p xmlns:a="http://schemas.openxmlformats.org/drawingml/2006/main">
+            <a:pPr>
+              <a:buNone/>
+              <a:defRPr sz="1350" b="0">
+                <a:solidFill>
+                  <a:srgbClr val="48636A"/>
+                </a:solidFill>
+                <a:latin typeface="Aptos"/>
+                <a:ea typeface="Aptos"/>
+                <a:cs typeface="Aptos"/>
+              </a:defRPr>
+            </a:pPr>
+            <a:r>
+              <a:rPr sz="1350" b="0">
+                <a:solidFill>
+                  <a:srgbClr val="48636A"/>
+                </a:solidFill>
+                <a:latin typeface="Aptos"/>
+                <a:ea typeface="Aptos"/>
+                <a:cs typeface="Aptos"/>
+              </a:rPr>
+              <a:t>4 / 8</a:t>
+            </a:r>
+          </a:p>
+        </p:txBody>
+      </p:sp>
+      <p:sp>
+        <p:nvSpPr>
+          <p:cNvPr id="3" name="">
+            <a:extLst xmlns:a="http://schemas.openxmlformats.org/drawingml/2006/main">
+              <a:ext uri="{FF2B5EF4-FFF2-40B4-BE49-F238E27FC236}">
+                <a16:creationId xmlns:a16="http://schemas.microsoft.com/office/drawing/2014/main" id="{AE2F4C86-A8A0-4EE9-BF6A-CE7D269C0CF5}"/>
+              </a:ext>
+            </a:extLst>
+          </p:cNvPr>
+          <p:cNvSpPr>
+            <a:spLocks xmlns:a="http://schemas.openxmlformats.org/drawingml/2006/main" noGrp="1"/>
+          </p:cNvSpPr>
+          <p:nvPr/>
+        </p:nvSpPr>
+        <p:spPr>
+          <a:xfrm xmlns:a="http://schemas.openxmlformats.org/drawingml/2006/main">
+            <a:off x="685800" y="1905000"/>
+            <a:ext cx="4762500" cy="857250"/>
+          </a:xfrm>
+          <a:prstGeom xmlns:a="http://schemas.openxmlformats.org/drawingml/2006/main" prst="rect">
+            <a:avLst/>
+          </a:prstGeom>
+          <a:noFill xmlns:a="http://schemas.openxmlformats.org/drawingml/2006/main"/>
+          <a:ln xmlns:a="http://schemas.openxmlformats.org/drawingml/2006/main" w="0">
+            <a:noFill/>
+          </a:ln>
+        </p:spPr>
+        <p:txBody>
+          <a:bodyPr xmlns:a="http://schemas.openxmlformats.org/drawingml/2006/main" anchor="ctr">
+            <a:noAutofit/>
+          </a:bodyPr>
+          <a:lstStyle xmlns:a="http://schemas.openxmlformats.org/drawingml/2006/main"/>
+          <a:p xmlns:a="http://schemas.openxmlformats.org/drawingml/2006/main">
+            <a:pPr>
+              <a:buNone/>
+              <a:defRPr sz="5400" b="1">
+                <a:solidFill>
+                  <a:srgbClr val="167A78"/>
+                </a:solidFill>
+                <a:latin typeface="Aptos"/>
+                <a:ea typeface="Aptos"/>
+                <a:cs typeface="Aptos"/>
+              </a:defRPr>
+            </a:pPr>
+            <a:r>
+              <a:rPr sz="5400" b="1">
+                <a:solidFill>
+                  <a:srgbClr val="167A78"/>
+                </a:solidFill>
+                <a:latin typeface="Aptos"/>
+                <a:ea typeface="Aptos"/>
+                <a:cs typeface="Aptos"/>
+              </a:rPr>
+              <a:t>mTORC1</a:t>
+            </a:r>
+          </a:p>
+        </p:txBody>
+      </p:sp>
+      <p:sp>
+        <p:nvSpPr>
+          <p:cNvPr id="4" name="">
+            <a:extLst xmlns:a="http://schemas.openxmlformats.org/drawingml/2006/main">
+              <a:ext uri="{FF2B5EF4-FFF2-40B4-BE49-F238E27FC236}">
+                <a16:creationId xmlns:a16="http://schemas.microsoft.com/office/drawing/2014/main" id="{10CD5A01-4553-4751-B921-AD1CB456D429}"/>
+              </a:ext>
+            </a:extLst>
+          </p:cNvPr>
+          <p:cNvSpPr>
+            <a:spLocks xmlns:a="http://schemas.openxmlformats.org/drawingml/2006/main" noGrp="1"/>
+          </p:cNvSpPr>
+          <p:nvPr/>
+        </p:nvSpPr>
+        <p:spPr>
+          <a:xfrm xmlns:a="http://schemas.openxmlformats.org/drawingml/2006/main">
+            <a:off x="723900" y="2857500"/>
+            <a:ext cx="4667250" cy="1028700"/>
+          </a:xfrm>
+          <a:prstGeom xmlns:a="http://schemas.openxmlformats.org/drawingml/2006/main" prst="rect">
+            <a:avLst/>
+          </a:prstGeom>
+          <a:noFill xmlns:a="http://schemas.openxmlformats.org/drawingml/2006/main"/>
+          <a:ln xmlns:a="http://schemas.openxmlformats.org/drawingml/2006/main" w="0">
+            <a:noFill/>
+          </a:ln>
+        </p:spPr>
+        <p:txBody>
+          <a:bodyPr xmlns:a="http://schemas.openxmlformats.org/drawingml/2006/main" anchor="ctr">
+            <a:noAutofit/>
+          </a:bodyPr>
+          <a:lstStyle xmlns:a="http://schemas.openxmlformats.org/drawingml/2006/main"/>
+          <a:p xmlns:a="http://schemas.openxmlformats.org/drawingml/2006/main">
+            <a:pPr>
+              <a:buNone/>
+              <a:defRPr sz="2475" b="0">
+                <a:solidFill>
+                  <a:srgbClr val="102E36"/>
+                </a:solidFill>
+                <a:latin typeface="Aptos"/>
+                <a:ea typeface="Aptos"/>
+                <a:cs typeface="Aptos"/>
+              </a:defRPr>
+            </a:pPr>
+            <a:r>
+              <a:rPr sz="2475" b="0">
+                <a:solidFill>
+                  <a:srgbClr val="102E36"/>
+                </a:solidFill>
+                <a:latin typeface="Aptos"/>
+                <a:ea typeface="Aptos"/>
+                <a:cs typeface="Aptos"/>
+              </a:rPr>
+              <a:t>A pathway that regulates cell growth</a:t>
+            </a:r>
+          </a:p>
+        </p:txBody>
+      </p:sp>
+      <p:sp>
+        <p:nvSpPr>
+          <p:cNvPr id="5" name="">
+            <a:extLst xmlns:a="http://schemas.openxmlformats.org/drawingml/2006/main">
+              <a:ext uri="{FF2B5EF4-FFF2-40B4-BE49-F238E27FC236}">
+                <a16:creationId xmlns:a16="http://schemas.microsoft.com/office/drawing/2014/main" id="{525D8CBD-3710-465A-A024-C7DF5F5424C4}"/>
+              </a:ext>
+            </a:extLst>
+          </p:cNvPr>
+          <p:cNvSpPr>
+            <a:spLocks xmlns:a="http://schemas.openxmlformats.org/drawingml/2006/main" noGrp="1"/>
+          </p:cNvSpPr>
+          <p:nvPr/>
+        </p:nvSpPr>
+        <p:spPr>
+          <a:xfrm xmlns:a="http://schemas.openxmlformats.org/drawingml/2006/main">
+            <a:off x="6286500" y="1828800"/>
+            <a:ext cx="4953000" cy="457200"/>
+          </a:xfrm>
+          <a:prstGeom xmlns:a="http://schemas.openxmlformats.org/drawingml/2006/main" prst="rect">
+            <a:avLst/>
+          </a:prstGeom>
+          <a:noFill xmlns:a="http://schemas.openxmlformats.org/drawingml/2006/main"/>
+          <a:ln xmlns:a="http://schemas.openxmlformats.org/drawingml/2006/main" w="0">
+            <a:noFill/>
+          </a:ln>
+        </p:spPr>
+        <p:txBody>
+          <a:bodyPr xmlns:a="http://schemas.openxmlformats.org/drawingml/2006/main" anchor="ctr">
+            <a:noAutofit/>
+          </a:bodyPr>
+          <a:lstStyle xmlns:a="http://schemas.openxmlformats.org/drawingml/2006/main"/>
+          <a:p xmlns:a="http://schemas.openxmlformats.org/drawingml/2006/main">
+            <a:pPr>
+              <a:buNone/>
+              <a:defRPr sz="2025" b="1">
+                <a:solidFill>
+                  <a:srgbClr val="167A78"/>
+                </a:solidFill>
+                <a:latin typeface="Aptos"/>
+                <a:ea typeface="Aptos"/>
+                <a:cs typeface="Aptos"/>
+              </a:defRPr>
+            </a:pPr>
+            <a:r>
+              <a:rPr sz="2025" b="1">
+                <a:solidFill>
+                  <a:srgbClr val="167A78"/>
+                </a:solidFill>
+                <a:latin typeface="Aptos"/>
+                <a:ea typeface="Aptos"/>
+                <a:cs typeface="Aptos"/>
+              </a:rPr>
+              <a:t>Evidence</a:t>
+            </a:r>
+          </a:p>
+        </p:txBody>
+      </p:sp>
+      <p:sp>
+        <p:nvSpPr>
+          <p:cNvPr id="6" name="">
+            <a:extLst xmlns:a="http://schemas.openxmlformats.org/drawingml/2006/main">
+              <a:ext uri="{FF2B5EF4-FFF2-40B4-BE49-F238E27FC236}">
+                <a16:creationId xmlns:a16="http://schemas.microsoft.com/office/drawing/2014/main" id="{6B65E5EB-60B3-4D4E-A857-083847F15C47}"/>
+              </a:ext>
+            </a:extLst>
+          </p:cNvPr>
+          <p:cNvSpPr>
+            <a:spLocks xmlns:a="http://schemas.openxmlformats.org/drawingml/2006/main" noGrp="1"/>
+          </p:cNvSpPr>
+          <p:nvPr/>
+        </p:nvSpPr>
+        <p:spPr>
+          <a:xfrm xmlns:a="http://schemas.openxmlformats.org/drawingml/2006/main">
+            <a:off x="6286500" y="2314575"/>
+            <a:ext cx="5048250" cy="1600200"/>
+          </a:xfrm>
+          <a:prstGeom xmlns:a="http://schemas.openxmlformats.org/drawingml/2006/main" prst="rect">
+            <a:avLst/>
+          </a:prstGeom>
+          <a:noFill xmlns:a="http://schemas.openxmlformats.org/drawingml/2006/main"/>
+          <a:ln xmlns:a="http://schemas.openxmlformats.org/drawingml/2006/main" w="0">
+            <a:noFill/>
+          </a:ln>
+        </p:spPr>
+        <p:txBody>
+          <a:bodyPr xmlns:a="http://schemas.openxmlformats.org/drawingml/2006/main" anchor="ctr">
+            <a:noAutofit/>
+          </a:bodyPr>
+          <a:lstStyle xmlns:a="http://schemas.openxmlformats.org/drawingml/2006/main"/>
+          <a:p xmlns:a="http://schemas.openxmlformats.org/drawingml/2006/main">
+            <a:pPr>
+              <a:buNone/>
+              <a:defRPr sz="2250" b="0">
+                <a:solidFill>
+                  <a:srgbClr val="102E36"/>
+                </a:solidFill>
+                <a:latin typeface="Aptos"/>
+                <a:ea typeface="Aptos"/>
+                <a:cs typeface="Aptos"/>
+              </a:defRPr>
+            </a:pPr>
+            <a:r>
+              <a:rPr sz="2250" b="0">
+                <a:solidFill>
+                  <a:srgbClr val="102E36"/>
+                </a:solidFill>
+                <a:latin typeface="Aptos"/>
+                <a:ea typeface="Aptos"/>
+                <a:cs typeface="Aptos"/>
+              </a:rPr>
+              <a:t>Qualitative carrier-mouse blot</a:t>
+            </a:r>
+          </a:p>
+          <a:p xmlns:a="http://schemas.openxmlformats.org/drawingml/2006/main">
+            <a:pPr>
+              <a:buNone/>
+              <a:defRPr sz="2250" b="0">
+                <a:solidFill>
+                  <a:srgbClr val="102E36"/>
+                </a:solidFill>
+                <a:latin typeface="Aptos"/>
+                <a:ea typeface="Aptos"/>
+                <a:cs typeface="Aptos"/>
+              </a:defRPr>
+            </a:pPr>
+            <a:r>
+              <a:rPr sz="2250" b="0">
+                <a:solidFill>
+                  <a:srgbClr val="102E36"/>
+                </a:solidFill>
+                <a:latin typeface="Aptos"/>
+                <a:ea typeface="Aptos"/>
+                <a:cs typeface="Aptos"/>
+              </a:rPr>
+              <a:t>Two mice per genotype</a:t>
+            </a:r>
+          </a:p>
+          <a:p xmlns:a="http://schemas.openxmlformats.org/drawingml/2006/main">
+            <a:pPr>
+              <a:buNone/>
+              <a:defRPr sz="2250" b="0">
+                <a:solidFill>
+                  <a:srgbClr val="102E36"/>
+                </a:solidFill>
+                <a:latin typeface="Aptos"/>
+                <a:ea typeface="Aptos"/>
+                <a:cs typeface="Aptos"/>
+              </a:defRPr>
+            </a:pPr>
+            <a:r>
+              <a:rPr sz="2250" b="0">
+                <a:solidFill>
+                  <a:srgbClr val="102E36"/>
+                </a:solidFill>
+                <a:latin typeface="Aptos"/>
+                <a:ea typeface="Aptos"/>
+                <a:cs typeface="Aptos"/>
+              </a:rPr>
+              <a:t>No phospho/total or statistics</a:t>
+            </a:r>
+          </a:p>
+        </p:txBody>
+      </p:sp>
+      <p:sp>
+        <p:nvSpPr>
+          <p:cNvPr id="7" name="">
+            <a:extLst xmlns:a="http://schemas.openxmlformats.org/drawingml/2006/main">
+              <a:ext uri="{FF2B5EF4-FFF2-40B4-BE49-F238E27FC236}">
+                <a16:creationId xmlns:a16="http://schemas.microsoft.com/office/drawing/2014/main" id="{C6AAF6BA-2CB7-4692-A1EE-56D61490A9EC}"/>
+              </a:ext>
+            </a:extLst>
+          </p:cNvPr>
+          <p:cNvSpPr>
+            <a:spLocks xmlns:a="http://schemas.openxmlformats.org/drawingml/2006/main" noGrp="1"/>
+          </p:cNvSpPr>
+          <p:nvPr/>
+        </p:nvSpPr>
+        <p:spPr>
+          <a:xfrm xmlns:a="http://schemas.openxmlformats.org/drawingml/2006/main">
+            <a:off x="6286500" y="4000500"/>
+            <a:ext cx="4762500" cy="457200"/>
+          </a:xfrm>
+          <a:prstGeom xmlns:a="http://schemas.openxmlformats.org/drawingml/2006/main" prst="rect">
+            <a:avLst/>
+          </a:prstGeom>
+          <a:noFill xmlns:a="http://schemas.openxmlformats.org/drawingml/2006/main"/>
+          <a:ln xmlns:a="http://schemas.openxmlformats.org/drawingml/2006/main" w="0">
+            <a:noFill/>
+          </a:ln>
+        </p:spPr>
+        <p:txBody>
+          <a:bodyPr xmlns:a="http://schemas.openxmlformats.org/drawingml/2006/main" anchor="ctr">
+            <a:noAutofit/>
+          </a:bodyPr>
+          <a:lstStyle xmlns:a="http://schemas.openxmlformats.org/drawingml/2006/main"/>
+          <a:p xmlns:a="http://schemas.openxmlformats.org/drawingml/2006/main">
+            <a:pPr>
+              <a:buNone/>
+              <a:defRPr sz="2025" b="1">
+                <a:solidFill>
+                  <a:srgbClr val="B07827"/>
+                </a:solidFill>
+                <a:latin typeface="Aptos"/>
+                <a:ea typeface="Aptos"/>
+                <a:cs typeface="Aptos"/>
+              </a:defRPr>
+            </a:pPr>
+            <a:r>
+              <a:rPr sz="2025" b="1">
+                <a:solidFill>
+                  <a:srgbClr val="B07827"/>
+                </a:solidFill>
+                <a:latin typeface="Aptos"/>
+                <a:ea typeface="Aptos"/>
+                <a:cs typeface="Aptos"/>
+              </a:rPr>
+              <a:t>Missing</a:t>
+            </a:r>
+          </a:p>
+        </p:txBody>
+      </p:sp>
+      <p:sp>
+        <p:nvSpPr>
+          <p:cNvPr id="8" name="">
+            <a:extLst xmlns:a="http://schemas.openxmlformats.org/drawingml/2006/main">
+              <a:ext uri="{FF2B5EF4-FFF2-40B4-BE49-F238E27FC236}">
+                <a16:creationId xmlns:a16="http://schemas.microsoft.com/office/drawing/2014/main" id="{9D180964-4EDC-40BB-89BA-11A5EB08A0CA}"/>
+              </a:ext>
+            </a:extLst>
+          </p:cNvPr>
+          <p:cNvSpPr>
+            <a:spLocks xmlns:a="http://schemas.openxmlformats.org/drawingml/2006/main" noGrp="1"/>
+          </p:cNvSpPr>
+          <p:nvPr/>
+        </p:nvSpPr>
+        <p:spPr>
+          <a:xfrm xmlns:a="http://schemas.openxmlformats.org/drawingml/2006/main">
+            <a:off x="6286500" y="4486275"/>
+            <a:ext cx="5048250" cy="1333500"/>
+          </a:xfrm>
+          <a:prstGeom xmlns:a="http://schemas.openxmlformats.org/drawingml/2006/main" prst="rect">
+            <a:avLst/>
+          </a:prstGeom>
+          <a:noFill xmlns:a="http://schemas.openxmlformats.org/drawingml/2006/main"/>
+          <a:ln xmlns:a="http://schemas.openxmlformats.org/drawingml/2006/main" w="0">
+            <a:noFill/>
+          </a:ln>
+        </p:spPr>
+        <p:txBody>
+          <a:bodyPr xmlns:a="http://schemas.openxmlformats.org/drawingml/2006/main" anchor="ctr">
+            <a:noAutofit/>
+          </a:bodyPr>
+          <a:lstStyle xmlns:a="http://schemas.openxmlformats.org/drawingml/2006/main"/>
+          <a:p xmlns:a="http://schemas.openxmlformats.org/drawingml/2006/main">
+            <a:pPr>
+              <a:buNone/>
+              <a:defRPr sz="2250" b="0">
+                <a:solidFill>
+                  <a:srgbClr val="102E36"/>
+                </a:solidFill>
+                <a:latin typeface="Aptos"/>
+                <a:ea typeface="Aptos"/>
+                <a:cs typeface="Aptos"/>
+              </a:defRPr>
+            </a:pPr>
+            <a:r>
+              <a:rPr sz="2250" b="0">
+                <a:solidFill>
+                  <a:srgbClr val="102E36"/>
+                </a:solidFill>
+                <a:latin typeface="Aptos"/>
+                <a:ea typeface="Aptos"/>
+                <a:cs typeface="Aptos"/>
+              </a:rPr>
+              <a:t>Muscle pathway excess and useful output remain unproved</a:t>
+            </a:r>
+          </a:p>
+        </p:txBody>
+      </p:sp>
+      <p:sp>
+        <p:nvSpPr>
+          <p:cNvPr id="9" name="">
+            <a:extLst xmlns:a="http://schemas.openxmlformats.org/drawingml/2006/main">
+              <a:ext uri="{FF2B5EF4-FFF2-40B4-BE49-F238E27FC236}">
+                <a16:creationId xmlns:a16="http://schemas.microsoft.com/office/drawing/2014/main" id="{02678E2D-02C6-4C36-8167-03523F2B3B6C}"/>
+              </a:ext>
+            </a:extLst>
+          </p:cNvPr>
+          <p:cNvSpPr>
+            <a:spLocks xmlns:a="http://schemas.openxmlformats.org/drawingml/2006/main" noGrp="1"/>
+          </p:cNvSpPr>
+          <p:nvPr/>
+        </p:nvSpPr>
+        <p:spPr>
+          <a:xfrm xmlns:a="http://schemas.openxmlformats.org/drawingml/2006/main">
+            <a:off x="685800" y="6067425"/>
+            <a:ext cx="10572750" cy="400050"/>
+          </a:xfrm>
+          <a:prstGeom xmlns:a="http://schemas.openxmlformats.org/drawingml/2006/main" prst="rect">
+            <a:avLst/>
+          </a:prstGeom>
+          <a:noFill xmlns:a="http://schemas.openxmlformats.org/drawingml/2006/main"/>
+          <a:ln xmlns:a="http://schemas.openxmlformats.org/drawingml/2006/main" w="0">
+            <a:noFill/>
+          </a:ln>
+        </p:spPr>
+        <p:txBody>
+          <a:bodyPr xmlns:a="http://schemas.openxmlformats.org/drawingml/2006/main" anchor="ctr">
+            <a:noAutofit/>
+          </a:bodyPr>
+          <a:lstStyle xmlns:a="http://schemas.openxmlformats.org/drawingml/2006/main"/>
+          <a:p xmlns:a="http://schemas.openxmlformats.org/drawingml/2006/main">
+            <a:pPr>
+              <a:buNone/>
+              <a:defRPr sz="1650" b="0">
+                <a:solidFill>
+                  <a:srgbClr val="48636A"/>
+                </a:solidFill>
+                <a:latin typeface="Aptos"/>
+                <a:ea typeface="Aptos"/>
+                <a:cs typeface="Aptos"/>
+              </a:defRPr>
+            </a:pPr>
+            <a:r>
+              <a:rPr sz="1650" b="0">
+                <a:solidFill>
+                  <a:srgbClr val="48636A"/>
+                </a:solidFill>
+                <a:latin typeface="Aptos"/>
+                <a:ea typeface="Aptos"/>
+                <a:cs typeface="Aptos"/>
+              </a:rPr>
+              <a:t>Rapamycin retained fly stem cells. Functional tissue rescue remains unestablished.</a:t>
+            </a:r>
+          </a:p>
+        </p:txBody>
+      </p:sp>
+    </p:spTree>
+    <p:extLst>
+      <p:ext uri="{BB962C8B-B14F-4D97-AF65-F5344CB8AC3E}">
+        <p14:creationId xmlns:p14="http://schemas.microsoft.com/office/powerpoint/2010/main" val="2020503096"/>
       </p:ext>
     </p:extLst>
   </p:cSld>
@@ -3770,6 +3792,7 @@
           <a:lstStyle xmlns:a="http://schemas.openxmlformats.org/drawingml/2006/main"/>
           <a:p xmlns:a="http://schemas.openxmlformats.org/drawingml/2006/main">
             <a:pPr>
+              <a:buNone/>
               <a:defRPr sz="3450" b="1">
                 <a:solidFill>
                   <a:srgbClr val="FFFFFF"/>
@@ -3788,7 +3811,7 @@
                 <a:ea typeface="Aptos"/>
                 <a:cs typeface="Aptos"/>
               </a:rPr>
-              <a:t>A better percentage can hide a loss</a:t>
+              <a:t>Cell selection and tissue output</a:t>
             </a:r>
           </a:p>
         </p:txBody>
@@ -3827,6 +3850,7 @@
           <a:lstStyle xmlns:a="http://schemas.openxmlformats.org/drawingml/2006/main"/>
           <a:p xmlns:a="http://schemas.openxmlformats.org/drawingml/2006/main">
             <a:pPr>
+              <a:buNone/>
               <a:defRPr sz="1350" b="0">
                 <a:solidFill>
                   <a:srgbClr val="B5CFCC"/>
@@ -3884,6 +3908,7 @@
           <a:lstStyle xmlns:a="http://schemas.openxmlformats.org/drawingml/2006/main"/>
           <a:p xmlns:a="http://schemas.openxmlformats.org/drawingml/2006/main">
             <a:pPr>
+              <a:buNone/>
               <a:defRPr sz="1725" b="0">
                 <a:solidFill>
                   <a:srgbClr val="B5CFCC"/>
@@ -3941,6 +3966,7 @@
           <a:lstStyle xmlns:a="http://schemas.openxmlformats.org/drawingml/2006/main"/>
           <a:p xmlns:a="http://schemas.openxmlformats.org/drawingml/2006/main">
             <a:pPr>
+              <a:buNone/>
               <a:defRPr sz="6900" b="1">
                 <a:solidFill>
                   <a:srgbClr val="80D2C5"/>
@@ -3998,6 +4024,7 @@
           <a:lstStyle xmlns:a="http://schemas.openxmlformats.org/drawingml/2006/main"/>
           <a:p xmlns:a="http://schemas.openxmlformats.org/drawingml/2006/main">
             <a:pPr>
+              <a:buNone/>
               <a:defRPr sz="2325" b="0">
                 <a:solidFill>
                   <a:srgbClr val="FFFFFF"/>
@@ -4021,6 +4048,7 @@
           </a:p>
           <a:p xmlns:a="http://schemas.openxmlformats.org/drawingml/2006/main">
             <a:pPr>
+              <a:buNone/>
               <a:defRPr sz="2325" b="0">
                 <a:solidFill>
                   <a:srgbClr val="FFFFFF"/>
@@ -4078,6 +4106,7 @@
           <a:lstStyle xmlns:a="http://schemas.openxmlformats.org/drawingml/2006/main"/>
           <a:p xmlns:a="http://schemas.openxmlformats.org/drawingml/2006/main">
             <a:pPr>
+              <a:buNone/>
               <a:defRPr sz="6900" b="1">
                 <a:solidFill>
                   <a:srgbClr val="EAC185"/>
@@ -4135,6 +4164,7 @@
           <a:lstStyle xmlns:a="http://schemas.openxmlformats.org/drawingml/2006/main"/>
           <a:p xmlns:a="http://schemas.openxmlformats.org/drawingml/2006/main">
             <a:pPr>
+              <a:buNone/>
               <a:defRPr sz="2325" b="0">
                 <a:solidFill>
                   <a:srgbClr val="FFFFFF"/>
@@ -4158,6 +4188,7 @@
           </a:p>
           <a:p xmlns:a="http://schemas.openxmlformats.org/drawingml/2006/main">
             <a:pPr>
+              <a:buNone/>
               <a:defRPr sz="2325" b="0">
                 <a:solidFill>
                   <a:srgbClr val="FFFFFF"/>
@@ -4215,6 +4246,7 @@
           <a:lstStyle xmlns:a="http://schemas.openxmlformats.org/drawingml/2006/main"/>
           <a:p xmlns:a="http://schemas.openxmlformats.org/drawingml/2006/main">
             <a:pPr>
+              <a:buNone/>
               <a:defRPr sz="2025" b="1">
                 <a:solidFill>
                   <a:srgbClr val="FFFFFF"/>
@@ -4233,7 +4265,7 @@
                 <a:ea typeface="Aptos"/>
                 <a:cs typeface="Aptos"/>
               </a:rPr>
-              <a:t>Simulated selection can improve the fraction while reducing total output.</a:t>
+              <a:t>An interactive tool for checking percentage gains against absolute output.</a:t>
             </a:r>
           </a:p>
         </p:txBody>
@@ -4272,6 +4304,7 @@
           <a:lstStyle xmlns:a="http://schemas.openxmlformats.org/drawingml/2006/main"/>
           <a:p xmlns:a="http://schemas.openxmlformats.org/drawingml/2006/main">
             <a:pPr>
+              <a:buNone/>
               <a:defRPr sz="1650" b="0">
                 <a:solidFill>
                   <a:srgbClr val="B5CFCC"/>
@@ -4358,6 +4391,7 @@
           <a:lstStyle xmlns:a="http://schemas.openxmlformats.org/drawingml/2006/main"/>
           <a:p xmlns:a="http://schemas.openxmlformats.org/drawingml/2006/main">
             <a:pPr>
+              <a:buNone/>
               <a:defRPr sz="3450" b="1">
                 <a:solidFill>
                   <a:srgbClr val="102E36"/>
@@ -4415,6 +4449,7 @@
           <a:lstStyle xmlns:a="http://schemas.openxmlformats.org/drawingml/2006/main"/>
           <a:p xmlns:a="http://schemas.openxmlformats.org/drawingml/2006/main">
             <a:pPr>
+              <a:buNone/>
               <a:defRPr sz="1350" b="0">
                 <a:solidFill>
                   <a:srgbClr val="48636A"/>
@@ -4440,7 +4475,7 @@
       </p:sp>
       <p:graphicFrame>
         <p:nvGraphicFramePr>
-          <p:cNvPr id="8" name=""/>
+          <p:cNvPr id="10" name=""/>
           <p:cNvGraphicFramePr/>
           <p:nvPr/>
         </p:nvGraphicFramePr>
@@ -4710,6 +4745,7 @@
           <a:lstStyle xmlns:a="http://schemas.openxmlformats.org/drawingml/2006/main"/>
           <a:p xmlns:a="http://schemas.openxmlformats.org/drawingml/2006/main">
             <a:pPr>
+              <a:buNone/>
               <a:defRPr sz="2025" b="1">
                 <a:solidFill>
                   <a:srgbClr val="167A78"/>
@@ -4767,6 +4803,7 @@
           <a:lstStyle xmlns:a="http://schemas.openxmlformats.org/drawingml/2006/main"/>
           <a:p xmlns:a="http://schemas.openxmlformats.org/drawingml/2006/main">
             <a:pPr>
+              <a:buNone/>
               <a:defRPr sz="1800" b="0">
                 <a:solidFill>
                   <a:srgbClr val="48636A"/>
@@ -4853,6 +4890,7 @@
           <a:lstStyle xmlns:a="http://schemas.openxmlformats.org/drawingml/2006/main"/>
           <a:p xmlns:a="http://schemas.openxmlformats.org/drawingml/2006/main">
             <a:pPr>
+              <a:buNone/>
               <a:defRPr sz="3450" b="1">
                 <a:solidFill>
                   <a:srgbClr val="102E36"/>
@@ -4910,6 +4948,7 @@
           <a:lstStyle xmlns:a="http://schemas.openxmlformats.org/drawingml/2006/main"/>
           <a:p xmlns:a="http://schemas.openxmlformats.org/drawingml/2006/main">
             <a:pPr>
+              <a:buNone/>
               <a:defRPr sz="1350" b="0">
                 <a:solidFill>
                   <a:srgbClr val="48636A"/>
@@ -4935,7 +4974,7 @@
       </p:sp>
       <p:graphicFrame>
         <p:nvGraphicFramePr>
-          <p:cNvPr id="7" name=""/>
+          <p:cNvPr id="9" name=""/>
           <p:cNvGraphicFramePr/>
           <p:nvPr/>
         </p:nvGraphicFramePr>
@@ -5205,6 +5244,7 @@
           <a:lstStyle xmlns:a="http://schemas.openxmlformats.org/drawingml/2006/main"/>
           <a:p xmlns:a="http://schemas.openxmlformats.org/drawingml/2006/main">
             <a:pPr>
+              <a:buNone/>
               <a:defRPr sz="2175" b="1">
                 <a:solidFill>
                   <a:srgbClr val="167A78"/>
@@ -5291,6 +5331,7 @@
           <a:lstStyle xmlns:a="http://schemas.openxmlformats.org/drawingml/2006/main"/>
           <a:p xmlns:a="http://schemas.openxmlformats.org/drawingml/2006/main">
             <a:pPr>
+              <a:buNone/>
               <a:defRPr sz="3450" b="1">
                 <a:solidFill>
                   <a:srgbClr val="FFFFFF"/>
@@ -5309,7 +5350,7 @@
                 <a:ea typeface="Aptos"/>
                 <a:cs typeface="Aptos"/>
               </a:rPr>
-              <a:t>A testable plan for a laboratory partner</a:t>
+              <a:t>Public reuse and the next experiment</a:t>
             </a:r>
           </a:p>
         </p:txBody>
@@ -5348,6 +5389,7 @@
           <a:lstStyle xmlns:a="http://schemas.openxmlformats.org/drawingml/2006/main"/>
           <a:p xmlns:a="http://schemas.openxmlformats.org/drawingml/2006/main">
             <a:pPr>
+              <a:buNone/>
               <a:defRPr sz="1350" b="0">
                 <a:solidFill>
                   <a:srgbClr val="B5CFCC"/>
@@ -5405,6 +5447,7 @@
           <a:lstStyle xmlns:a="http://schemas.openxmlformats.org/drawingml/2006/main"/>
           <a:p xmlns:a="http://schemas.openxmlformats.org/drawingml/2006/main">
             <a:pPr>
+              <a:buNone/>
               <a:defRPr sz="2475" b="1">
                 <a:solidFill>
                   <a:srgbClr val="80D2C5"/>
@@ -5462,6 +5505,7 @@
           <a:lstStyle xmlns:a="http://schemas.openxmlformats.org/drawingml/2006/main"/>
           <a:p xmlns:a="http://schemas.openxmlformats.org/drawingml/2006/main">
             <a:pPr>
+              <a:buNone/>
               <a:defRPr sz="2550" b="0">
                 <a:solidFill>
                   <a:srgbClr val="FFFFFF"/>
@@ -5480,11 +5524,12 @@
                 <a:ea typeface="Aptos"/>
                 <a:cs typeface="Aptos"/>
               </a:rPr>
-              <a:t>Sequence review</a:t>
+              <a:t>Two sequence examples</a:t>
             </a:r>
           </a:p>
           <a:p xmlns:a="http://schemas.openxmlformats.org/drawingml/2006/main">
             <a:pPr>
+              <a:buNone/>
               <a:defRPr sz="2550" b="0">
                 <a:solidFill>
                   <a:srgbClr val="FFFFFF"/>
@@ -5503,11 +5548,12 @@
                 <a:ea typeface="Aptos"/>
                 <a:cs typeface="Aptos"/>
               </a:rPr>
-              <a:t>Evidence review</a:t>
+              <a:t>BUB1B and synthetic TRIP13</a:t>
             </a:r>
           </a:p>
           <a:p xmlns:a="http://schemas.openxmlformats.org/drawingml/2006/main">
             <a:pPr>
+              <a:buNone/>
               <a:defRPr sz="2550" b="0">
                 <a:solidFill>
                   <a:srgbClr val="FFFFFF"/>
@@ -5526,7 +5572,7 @@
                 <a:ea typeface="Aptos"/>
                 <a:cs typeface="Aptos"/>
               </a:rPr>
-              <a:t>Computational study design</a:t>
+              <a:t>Reusable output explorer</a:t>
             </a:r>
           </a:p>
         </p:txBody>
@@ -5565,6 +5611,7 @@
           <a:lstStyle xmlns:a="http://schemas.openxmlformats.org/drawingml/2006/main"/>
           <a:p xmlns:a="http://schemas.openxmlformats.org/drawingml/2006/main">
             <a:pPr>
+              <a:buNone/>
               <a:defRPr sz="2475" b="1">
                 <a:solidFill>
                   <a:srgbClr val="EAC185"/>
@@ -5622,6 +5669,7 @@
           <a:lstStyle xmlns:a="http://schemas.openxmlformats.org/drawingml/2006/main"/>
           <a:p xmlns:a="http://schemas.openxmlformats.org/drawingml/2006/main">
             <a:pPr>
+              <a:buNone/>
               <a:defRPr sz="2550" b="0">
                 <a:solidFill>
                   <a:srgbClr val="FFFFFF"/>
@@ -5645,6 +5693,7 @@
           </a:p>
           <a:p xmlns:a="http://schemas.openxmlformats.org/drawingml/2006/main">
             <a:pPr>
+              <a:buNone/>
               <a:defRPr sz="2550" b="0">
                 <a:solidFill>
                   <a:srgbClr val="FFFFFF"/>
@@ -5668,6 +5717,7 @@
           </a:p>
           <a:p xmlns:a="http://schemas.openxmlformats.org/drawingml/2006/main">
             <a:pPr>
+              <a:buNone/>
               <a:defRPr sz="2550" b="0">
                 <a:solidFill>
                   <a:srgbClr val="FFFFFF"/>
@@ -5725,6 +5775,7 @@
           <a:lstStyle xmlns:a="http://schemas.openxmlformats.org/drawingml/2006/main"/>
           <a:p xmlns:a="http://schemas.openxmlformats.org/drawingml/2006/main">
             <a:pPr>
+              <a:buNone/>
               <a:defRPr sz="2775" b="1">
                 <a:solidFill>
                   <a:srgbClr val="FFFFFF"/>
@@ -5743,7 +5794,7 @@
                 <a:ea typeface="Aptos"/>
                 <a:cs typeface="Aptos"/>
               </a:rPr>
-              <a:t>Advance a medicine with measured benefit, or explain why none passes.</a:t>
+              <a:t>Niacin leads. Useful muscle and preserved renewal decide advancement.</a:t>
             </a:r>
           </a:p>
         </p:txBody>
@@ -5782,6 +5833,7 @@
           <a:lstStyle xmlns:a="http://schemas.openxmlformats.org/drawingml/2006/main"/>
           <a:p xmlns:a="http://schemas.openxmlformats.org/drawingml/2006/main">
             <a:pPr>
+              <a:buNone/>
               <a:defRPr sz="1500" b="0">
                 <a:solidFill>
                   <a:srgbClr val="B5CFCC"/>

</xml_diff>

<commit_message>
Integrate apitegromab comparison and replace public Vimeo pitch
</commit_message>
<xml_diff>
--- a/reports/media/jeweled_track2_slides.pptx
+++ b/reports/media/jeweled_track2_slides.pptx
@@ -2,20 +2,20 @@
 <file path=ppt/presentation.xml><?xml version="1.0" encoding="utf-8"?>
 <p:presentation xmlns:p="http://schemas.openxmlformats.org/presentationml/2006/main">
   <p:sldMasterIdLst>
-    <p:sldMasterId xmlns:r="http://schemas.openxmlformats.org/officeDocument/2006/relationships" id="2147483648" r:id="R5a651e2cc8be4ae4"/>
+    <p:sldMasterId xmlns:r="http://schemas.openxmlformats.org/officeDocument/2006/relationships" id="2147483648" r:id="Rc0df8245f2f44b62"/>
   </p:sldMasterIdLst>
   <p:notesMasterIdLst>
-    <p:notesMasterId xmlns:r="http://schemas.openxmlformats.org/officeDocument/2006/relationships" r:id="R00c31f57320247b5"/>
+    <p:notesMasterId xmlns:r="http://schemas.openxmlformats.org/officeDocument/2006/relationships" r:id="R4221e5de6c3e4a56"/>
   </p:notesMasterIdLst>
   <p:sldIdLst>
-    <p:sldId xmlns:r="http://schemas.openxmlformats.org/officeDocument/2006/relationships" id="256" r:id="R5c49f40aa19541bc"/>
-    <p:sldId xmlns:r="http://schemas.openxmlformats.org/officeDocument/2006/relationships" id="257" r:id="R0d4f3e76154049bd"/>
-    <p:sldId xmlns:r="http://schemas.openxmlformats.org/officeDocument/2006/relationships" id="258" r:id="Ref02a9c6f2704ca4"/>
-    <p:sldId xmlns:r="http://schemas.openxmlformats.org/officeDocument/2006/relationships" id="259" r:id="R99aabc55bfbb4c0c"/>
-    <p:sldId xmlns:r="http://schemas.openxmlformats.org/officeDocument/2006/relationships" id="260" r:id="Rf90daa3f5d82406c"/>
-    <p:sldId xmlns:r="http://schemas.openxmlformats.org/officeDocument/2006/relationships" id="261" r:id="R45dd65b31e47470c"/>
-    <p:sldId xmlns:r="http://schemas.openxmlformats.org/officeDocument/2006/relationships" id="262" r:id="Rd3c56b7ef7bc466f"/>
-    <p:sldId xmlns:r="http://schemas.openxmlformats.org/officeDocument/2006/relationships" id="263" r:id="R0573f7a4efc64754"/>
+    <p:sldId xmlns:r="http://schemas.openxmlformats.org/officeDocument/2006/relationships" id="256" r:id="R6a03a173dfb045ff"/>
+    <p:sldId xmlns:r="http://schemas.openxmlformats.org/officeDocument/2006/relationships" id="257" r:id="R7543966d8bd64270"/>
+    <p:sldId xmlns:r="http://schemas.openxmlformats.org/officeDocument/2006/relationships" id="258" r:id="R56a45eb5fd1b4f49"/>
+    <p:sldId xmlns:r="http://schemas.openxmlformats.org/officeDocument/2006/relationships" id="259" r:id="Rf0c5f8fe45bf43f7"/>
+    <p:sldId xmlns:r="http://schemas.openxmlformats.org/officeDocument/2006/relationships" id="260" r:id="R67ab98a3f3b54f5d"/>
+    <p:sldId xmlns:r="http://schemas.openxmlformats.org/officeDocument/2006/relationships" id="261" r:id="R3e85a9f121d54cc8"/>
+    <p:sldId xmlns:r="http://schemas.openxmlformats.org/officeDocument/2006/relationships" id="262" r:id="R68b9fbdf1d9d4bab"/>
+    <p:sldId xmlns:r="http://schemas.openxmlformats.org/officeDocument/2006/relationships" id="263" r:id="Rf6083df26f274a40"/>
   </p:sldIdLst>
   <p:sldSz cx="12192000" cy="6858000"/>
   <p:notesSz cx="6858000" cy="9144000"/>
@@ -479,7 +479,17 @@
           </a:p>
           <a:p xmlns:a="http://schemas.openxmlformats.org/drawingml/2006/main">
             <a:r>
-              <a:t>Research proposal. No biological drug experiment has run. Synthetic TRIP13 is a public transfer demonstration, not a second analyzed patient. Niacin has no demonstrated BUB1B rescue. Narration: Cartesia Sonic 3.6, stock Skylar.</a:t>
+              <a:t>The cover illustration uses OpenAI-generated conceptual art. It is not a patient image or experimental result.</a:t>
+            </a:r>
+          </a:p>
+          <a:p xmlns:a="http://schemas.openxmlformats.org/drawingml/2006/main">
+            <a:r>
+              <a:t/>
+            </a:r>
+          </a:p>
+          <a:p xmlns:a="http://schemas.openxmlformats.org/drawingml/2006/main">
+            <a:r>
+              <a:t>Research proposal. No biological drug experiment has run. Neither medicine has demonstrated rescue of this BUB1B genotype.</a:t>
             </a:r>
           </a:p>
         </p:txBody>
@@ -549,7 +559,7 @@
           <a:lstStyle xmlns:a="http://schemas.openxmlformats.org/drawingml/2006/main"/>
           <a:p xmlns:a="http://schemas.openxmlformats.org/drawingml/2006/main">
             <a:r>
-              <a:t>Bub one B makes the checkpoint protein Bub R one. Our stop-plus-missense pair matches a reported MVA one pattern: reduced protein supply. The missense protein's stability and function remain unmeasured. Trans phase needs confirmation. Confirmed cis retires this pair as the compound-heterozygous explanation.</a:t>
+              <a:t>BUB1B makes the checkpoint protein BUBR1. Our stop-plus-missense pair matches a reported MVA1 pattern: reduced protein supply. The missense protein's stability and function remain unmeasured. Trans phase needs confirmation. Confirmed cis retires this pair as the compound-heterozygous explanation.</a:t>
             </a:r>
           </a:p>
           <a:p xmlns:a="http://schemas.openxmlformats.org/drawingml/2006/main">
@@ -589,7 +599,17 @@
           </a:p>
           <a:p xmlns:a="http://schemas.openxmlformats.org/drawingml/2006/main">
             <a:r>
-              <a:t>Research proposal. No biological drug experiment has run. Synthetic TRIP13 is a public transfer demonstration, not a second analyzed patient. Niacin has no demonstrated BUB1B rescue. Narration: Cartesia Sonic 3.6, stock Skylar.</a:t>
+              <a:t>Trans phase is unobserved. Confirmed cis retires this pair as the compound-heterozygous explanation.</a:t>
+            </a:r>
+          </a:p>
+          <a:p xmlns:a="http://schemas.openxmlformats.org/drawingml/2006/main">
+            <a:r>
+              <a:t/>
+            </a:r>
+          </a:p>
+          <a:p xmlns:a="http://schemas.openxmlformats.org/drawingml/2006/main">
+            <a:r>
+              <a:t>Research proposal. No biological drug experiment has run. Neither medicine has demonstrated rescue of this BUB1B genotype.</a:t>
             </a:r>
           </a:p>
         </p:txBody>
@@ -659,7 +679,7 @@
           <a:lstStyle xmlns:a="http://schemas.openxmlformats.org/drawingml/2006/main"/>
           <a:p xmlns:a="http://schemas.openxmlformats.org/drawingml/2006/main">
             <a:r>
-              <a:t>Niacin is our lead because it targets the protein-supply hypothesis. It raised muscle N A D in another myopathy. Separate experiments connect N A D and SIRT two to Bub R one stability. Niacin has not rescued this genotype. We test whether it increases usable protein and useful muscle.</a:t>
+              <a:t>Niacin is our lead because it targets the protein-supply hypothesis. It raised muscle NAD in another myopathy. Separate experiments connect NAD and SIRT2 to BUBR1 stability. Niacin has not rescued this genotype. We test whether it increases usable protein and useful muscle.</a:t>
             </a:r>
           </a:p>
           <a:p xmlns:a="http://schemas.openxmlformats.org/drawingml/2006/main">
@@ -694,7 +714,17 @@
           </a:p>
           <a:p xmlns:a="http://schemas.openxmlformats.org/drawingml/2006/main">
             <a:r>
-              <a:t>Research proposal. No biological drug experiment has run. Synthetic TRIP13 is a public transfer demonstration, not a second analyzed patient. Niacin has no demonstrated BUB1B rescue. Narration: Cartesia Sonic 3.6, stock Skylar.</a:t>
+              <a:t>The human niacin study was small and open-label. Treated healthy controls also gained strength. North et al. used NMN for pharmacological BUBR1 abundance experiments and genetic SIRT2 overexpression for the BubR1-H/H survival intervention.</a:t>
+            </a:r>
+          </a:p>
+          <a:p xmlns:a="http://schemas.openxmlformats.org/drawingml/2006/main">
+            <a:r>
+              <a:t/>
+            </a:r>
+          </a:p>
+          <a:p xmlns:a="http://schemas.openxmlformats.org/drawingml/2006/main">
+            <a:r>
+              <a:t>Research proposal. No biological drug experiment has run. Neither medicine has demonstrated rescue of this BUB1B genotype.</a:t>
             </a:r>
           </a:p>
         </p:txBody>
@@ -764,7 +794,7 @@
           <a:lstStyle xmlns:a="http://schemas.openxmlformats.org/drawingml/2006/main"/>
           <a:p xmlns:a="http://schemas.openxmlformats.org/drawingml/2006/main">
             <a:r>
-              <a:t>Everolimus is our downstream probe. It inhibits em tor complex one, a growth pathway. A small carrier-mouse blot showed stronger phosphoprotein bands, without quantified pathway activity. Rapamycin preserved stem-cell numbers in a different fly model. Neither establishes muscle rescue. We require functional benefit with preserved growth and renewal.</a:t>
+              <a:t>Apitegromab is our muscle-support comparator. It blocks myostatin activation and improved motor function in a randomized spinal-muscular-atrophy trial. It now has an approved use, but no MVA evidence. Fractures are a labeled risk. We test useful muscle output, without claiming that larger muscles repair the chromosome defect.</a:t>
             </a:r>
           </a:p>
           <a:p xmlns:a="http://schemas.openxmlformats.org/drawingml/2006/main">
@@ -779,22 +809,32 @@
           </a:p>
           <a:p xmlns:a="http://schemas.openxmlformats.org/drawingml/2006/main">
             <a:r>
-              <a:t>https://www.jci.org/articles/view/126863/version/2</a:t>
-            </a:r>
-          </a:p>
-          <a:p xmlns:a="http://schemas.openxmlformats.org/drawingml/2006/main">
-            <a:r>
-              <a:t>https://dailymed.nlm.nih.gov/dailymed/fda/fdaDrugXsl.cfm?setid=2150f73a-179b-4afc-b8ce-67c85cc72f04</a:t>
-            </a:r>
-          </a:p>
-          <a:p xmlns:a="http://schemas.openxmlformats.org/drawingml/2006/main">
-            <a:r>
-              <a:t>reports/appendices/track2-evidence-pipeline.md</a:t>
-            </a:r>
-          </a:p>
-          <a:p xmlns:a="http://schemas.openxmlformats.org/drawingml/2006/main">
-            <a:r>
-              <a:t>https://pmc.ncbi.nlm.nih.gov/articles/PMC13121444/</a:t>
+              <a:t>workflow/track2-drug-census/apitegromab-review.md</a:t>
+            </a:r>
+          </a:p>
+          <a:p xmlns:a="http://schemas.openxmlformats.org/drawingml/2006/main">
+            <a:r>
+              <a:t>https://pubmed.ncbi.nlm.nih.gov/40818473/</a:t>
+            </a:r>
+          </a:p>
+          <a:p xmlns:a="http://schemas.openxmlformats.org/drawingml/2006/main">
+            <a:r>
+              <a:t>https://doi.org/10.1016/S1474-4422(25)00225-X</a:t>
+            </a:r>
+          </a:p>
+          <a:p xmlns:a="http://schemas.openxmlformats.org/drawingml/2006/main">
+            <a:r>
+              <a:t>https://pmc.ncbi.nlm.nih.gov/articles/PMC8189951/</a:t>
+            </a:r>
+          </a:p>
+          <a:p xmlns:a="http://schemas.openxmlformats.org/drawingml/2006/main">
+            <a:r>
+              <a:t>https://dailymed.nlm.nih.gov/dailymed/drugInfo.cfm?setid=b1cd8ab8-8a10-48ed-9806-75a44f22b963</a:t>
+            </a:r>
+          </a:p>
+          <a:p xmlns:a="http://schemas.openxmlformats.org/drawingml/2006/main">
+            <a:r>
+              <a:t>https://www.fda.gov/drugs/news-events-human-drugs/fda-approves-first-therapy-target-muscle-loss-spinal-muscular-atrophy</a:t>
             </a:r>
           </a:p>
           <a:p xmlns:a="http://schemas.openxmlformats.org/drawingml/2006/main">
@@ -804,7 +844,17 @@
           </a:p>
           <a:p xmlns:a="http://schemas.openxmlformats.org/drawingml/2006/main">
             <a:r>
-              <a:t>Research proposal. No biological drug experiment has run. Synthetic TRIP13 is a public transfer demonstration, not a second analyzed patient. Niacin has no demonstrated BUB1B rescue. Narration: Cartesia Sonic 3.6, stock Skylar.</a:t>
+              <a:t>HFMSE is the Hammersmith Functional Motor Scale Expanded. The positive primary result is the pooled apitegromab-versus-placebo comparison in 156 participants aged 2–12 with SMA receiving nusinersen or risdiplam. LS difference at 12 months: 1.8 points, 95% CI 0.30–3.32, p=0.019. This is neither every individual dose comparison nor evidence for MVA. FDA approved ISEMBYLD on 11 September 2026 for SMA from age 2 with SMN2-targeted treatment. The label warns of fractures. Increased muscle mass does not establish chromosome repair. Confirm target availability and drug-specific engagement before interpreting a model result. No patient dose is proposed.</a:t>
+            </a:r>
+          </a:p>
+          <a:p xmlns:a="http://schemas.openxmlformats.org/drawingml/2006/main">
+            <a:r>
+              <a:t/>
+            </a:r>
+          </a:p>
+          <a:p xmlns:a="http://schemas.openxmlformats.org/drawingml/2006/main">
+            <a:r>
+              <a:t>Research proposal. No biological drug experiment has run. Neither medicine has demonstrated rescue of this BUB1B genotype.</a:t>
             </a:r>
           </a:p>
         </p:txBody>
@@ -914,7 +964,17 @@
           </a:p>
           <a:p xmlns:a="http://schemas.openxmlformats.org/drawingml/2006/main">
             <a:r>
-              <a:t>Research proposal. No biological drug experiment has run. Synthetic TRIP13 is a public transfer demonstration, not a second analyzed patient. Niacin has no demonstrated BUB1B rescue. Narration: Cartesia Sonic 3.6, stock Skylar.</a:t>
+              <a:t>Aggregate-population simulation, not observed drug response, patient measurement or actual lineage pedigree. The scenario illustrates the difference between a percentage and absolute tissue output.</a:t>
+            </a:r>
+          </a:p>
+          <a:p xmlns:a="http://schemas.openxmlformats.org/drawingml/2006/main">
+            <a:r>
+              <a:t/>
+            </a:r>
+          </a:p>
+          <a:p xmlns:a="http://schemas.openxmlformats.org/drawingml/2006/main">
+            <a:r>
+              <a:t>Research proposal. No biological drug experiment has run. Neither medicine has demonstrated rescue of this BUB1B genotype.</a:t>
             </a:r>
           </a:p>
         </p:txBody>
@@ -1009,7 +1069,17 @@
           </a:p>
           <a:p xmlns:a="http://schemas.openxmlformats.org/drawingml/2006/main">
             <a:r>
-              <a:t>Research proposal. No biological drug experiment has run. Synthetic TRIP13 is a public transfer demonstration, not a second analyzed patient. Niacin has no demonstrated BUB1B rescue. Narration: Cartesia Sonic 3.6, stock Skylar.</a:t>
+              <a:t>Test each medicine separately with measured exposure and drug-specific engagement. Apitegromab requires the relevant myostatin precursor/activation system. Culture experiments do not resolve longer-term bone or tumor outcomes.</a:t>
+            </a:r>
+          </a:p>
+          <a:p xmlns:a="http://schemas.openxmlformats.org/drawingml/2006/main">
+            <a:r>
+              <a:t/>
+            </a:r>
+          </a:p>
+          <a:p xmlns:a="http://schemas.openxmlformats.org/drawingml/2006/main">
+            <a:r>
+              <a:t>Research proposal. No biological drug experiment has run. Neither medicine has demonstrated rescue of this BUB1B genotype.</a:t>
             </a:r>
           </a:p>
         </p:txBody>
@@ -1079,7 +1149,7 @@
           <a:lstStyle xmlns:a="http://schemas.openxmlformats.org/drawingml/2006/main"/>
           <a:p xmlns:a="http://schemas.openxmlformats.org/drawingml/2006/main">
             <a:r>
-              <a:t>Arimoclomol remains a reserve because rescue of this protein is unproved. Removing senescent cells has strong genetic mouse evidence, but some drugs also damage repair in young muscle. We investigate that mechanism in parallel. Transcript rescue and other alternatives have explicit promotion tests in our report.</a:t>
+              <a:t>Our public drug census screened over fifteen thousand clinical and regulatory entries. It made apitegromab a stronger downstream candidate than everolimus for muscle function. Everolimus remains a conditional signaling probe. Other same-gene genetic and drug findings have explicit limitations. Missing evidence stays unknown rather than becoming a failed drug.</a:t>
             </a:r>
           </a:p>
           <a:p xmlns:a="http://schemas.openxmlformats.org/drawingml/2006/main">
@@ -1094,27 +1164,42 @@
           </a:p>
           <a:p xmlns:a="http://schemas.openxmlformats.org/drawingml/2006/main">
             <a:r>
+              <a:t>workflow/track2-drug-census/README.md</a:t>
+            </a:r>
+          </a:p>
+          <a:p xmlns:a="http://schemas.openxmlformats.org/drawingml/2006/main">
+            <a:r>
+              <a:t>workflow/track2-drug-census/decision-report.md</a:t>
+            </a:r>
+          </a:p>
+          <a:p xmlns:a="http://schemas.openxmlformats.org/drawingml/2006/main">
+            <a:r>
+              <a:t>workflow/track2-drug-census/apitegromab-review.md</a:t>
+            </a:r>
+          </a:p>
+          <a:p xmlns:a="http://schemas.openxmlformats.org/drawingml/2006/main">
+            <a:r>
               <a:t>reports/appendices/track2-route-decisions.md</a:t>
             </a:r>
           </a:p>
           <a:p xmlns:a="http://schemas.openxmlformats.org/drawingml/2006/main">
             <a:r>
-              <a:t>https://pmc.ncbi.nlm.nih.gov/articles/PMC3468323/</a:t>
-            </a:r>
-          </a:p>
-          <a:p xmlns:a="http://schemas.openxmlformats.org/drawingml/2006/main">
-            <a:r>
-              <a:t>https://pubmed.ncbi.nlm.nih.gov/34904366/</a:t>
-            </a:r>
-          </a:p>
-          <a:p xmlns:a="http://schemas.openxmlformats.org/drawingml/2006/main">
-            <a:r>
               <a:t/>
             </a:r>
           </a:p>
           <a:p xmlns:a="http://schemas.openxmlformats.org/drawingml/2006/main">
             <a:r>
-              <a:t>Research proposal. No biological drug experiment has run. Synthetic TRIP13 is a public transfer demonstration, not a second analyzed patient. Niacin has no demonstrated BUB1B rescue. Narration: Cartesia Sonic 3.6, stock Skylar.</a:t>
+              <a:t>The census enumerates clinical-development and regulatory entries, not a complete universe of unique medicines. Only explicitly appraised candidates have a manually reasoned competitiveness decision. Same-gene findings include conference-only AZD1152/barasertib survival evidence without sarcopenia improvement, and genetic FRZB/PAK2 findings with no qualified drug rescue. Missing evidence is unknown rather than a negative drug experiment.</a:t>
+            </a:r>
+          </a:p>
+          <a:p xmlns:a="http://schemas.openxmlformats.org/drawingml/2006/main">
+            <a:r>
+              <a:t/>
+            </a:r>
+          </a:p>
+          <a:p xmlns:a="http://schemas.openxmlformats.org/drawingml/2006/main">
+            <a:r>
+              <a:t>Research proposal. No biological drug experiment has run. Neither medicine has demonstrated rescue of this BUB1B genotype.</a:t>
             </a:r>
           </a:p>
         </p:txBody>
@@ -1184,7 +1269,7 @@
           <a:lstStyle xmlns:a="http://schemas.openxmlformats.org/drawingml/2006/main"/>
           <a:p xmlns:a="http://schemas.openxmlformats.org/drawingml/2006/main">
             <a:r>
-              <a:t>We also ran the workflow on a public, synthetic TRIP thirteen example. It shows why a Bub R one restoration hypothesis cannot simply transfer to another gene. That demonstrates reuse, not treatment validation. Next we need a consented muscle model and laboratory partner to test niacin, with everolimus as comparator.</a:t>
+              <a:t>We also ran the workflow on a public, synthetic TRIP13 example. It shows why a BUBR1 restoration hypothesis cannot simply transfer to another gene. That demonstrates reuse, not treatment validation. Next we need a consented muscle model and laboratory partner to test niacin and apitegromab separately.</a:t>
             </a:r>
           </a:p>
           <a:p xmlns:a="http://schemas.openxmlformats.org/drawingml/2006/main">
@@ -1214,12 +1299,27 @@
           </a:p>
           <a:p xmlns:a="http://schemas.openxmlformats.org/drawingml/2006/main">
             <a:r>
+              <a:t>workflow/track2-drug-census/decision-report.md</a:t>
+            </a:r>
+          </a:p>
+          <a:p xmlns:a="http://schemas.openxmlformats.org/drawingml/2006/main">
+            <a:r>
               <a:t/>
             </a:r>
           </a:p>
           <a:p xmlns:a="http://schemas.openxmlformats.org/drawingml/2006/main">
             <a:r>
-              <a:t>Research proposal. No biological drug experiment has run. Synthetic TRIP13 is a public transfer demonstration, not a second analyzed patient. Niacin has no demonstrated BUB1B rescue. Narration: Cartesia Sonic 3.6, stock Skylar.</a:t>
+              <a:t>The TRIP13 example is synthetic and demonstrates workflow reuse, not validation in a second patient. The proposed separate medication experiments are niacin and apitegromab. Everolimus remains a conditional signaling probe.</a:t>
+            </a:r>
+          </a:p>
+          <a:p xmlns:a="http://schemas.openxmlformats.org/drawingml/2006/main">
+            <a:r>
+              <a:t/>
+            </a:r>
+          </a:p>
+          <a:p xmlns:a="http://schemas.openxmlformats.org/drawingml/2006/main">
+            <a:r>
+              <a:t>Research proposal. No biological drug experiment has run. Neither medicine has demonstrated rescue of this BUB1B genotype.</a:t>
             </a:r>
           </a:p>
         </p:txBody>
@@ -1287,7 +1387,7 @@
   </p:cSld>
   <p:clrMap bg1="lt1" tx1="dk1" bg2="lt2" tx2="dk2" accent1="accent1" accent2="accent2" accent3="accent3" accent4="accent4" accent5="accent5" accent6="accent6" hlink="hlink" folHlink="folHlink"/>
   <p:sldLayoutIdLst>
-    <p:sldLayoutId xmlns:r="http://schemas.openxmlformats.org/officeDocument/2006/relationships" id="2147483649" r:id="R36b2a6ad9b224e9f"/>
+    <p:sldLayoutId xmlns:r="http://schemas.openxmlformats.org/officeDocument/2006/relationships" id="2147483649" r:id="R7d2b0957ded24fc3"/>
   </p:sldLayoutIdLst>
   <p:txStyles>
     <p:titleStyle>
@@ -1900,7 +2000,7 @@
           <p:nvPr/>
         </p:nvPicPr>
         <p:blipFill>
-          <a:blip xmlns:r="http://schemas.openxmlformats.org/officeDocument/2006/relationships" xmlns:a="http://schemas.openxmlformats.org/drawingml/2006/main" r:embed="R043c97924d484d44"/>
+          <a:blip xmlns:r="http://schemas.openxmlformats.org/officeDocument/2006/relationships" xmlns:a="http://schemas.openxmlformats.org/drawingml/2006/main" r:embed="R916b3f793e114821"/>
           <a:srcRect xmlns:a="http://schemas.openxmlformats.org/drawingml/2006/main" l="0" t="27" r="0" b="27"/>
           <a:stretch xmlns:a="http://schemas.openxmlformats.org/drawingml/2006/main">
             <a:fillRect l="0" t="0" r="0" b="0"/>
@@ -3212,7 +3312,7 @@
                 <a:ea typeface="Aptos"/>
                 <a:cs typeface="Aptos"/>
               </a:rPr>
-              <a:t>Everolimus is a downstream probe</a:t>
+              <a:t>Apitegromab tests muscle compensation</a:t>
             </a:r>
           </a:p>
         </p:txBody>
@@ -3328,7 +3428,7 @@
                 <a:ea typeface="Aptos"/>
                 <a:cs typeface="Aptos"/>
               </a:rPr>
-              <a:t>mTORC1</a:t>
+              <a:t>+1.8</a:t>
             </a:r>
           </a:p>
         </p:txBody>
@@ -3349,8 +3449,8 @@
         </p:nvSpPr>
         <p:spPr>
           <a:xfrm xmlns:a="http://schemas.openxmlformats.org/drawingml/2006/main">
-            <a:off x="723900" y="2857500"/>
-            <a:ext cx="4667250" cy="1028700"/>
+            <a:off x="723900" y="2809875"/>
+            <a:ext cx="4857750" cy="1381125"/>
           </a:xfrm>
           <a:prstGeom xmlns:a="http://schemas.openxmlformats.org/drawingml/2006/main" prst="rect">
             <a:avLst/>
@@ -3386,7 +3486,9 @@
                 <a:ea typeface="Aptos"/>
                 <a:cs typeface="Aptos"/>
               </a:rPr>
-              <a:t>A pathway that regulates cell growth</a:t>
+              <a:t>HFMSE points vs placebo
+95% CI 0.30–3.32
+At 12 months</a:t>
             </a:r>
           </a:p>
         </p:txBody>
@@ -3444,7 +3546,7 @@
                 <a:ea typeface="Aptos"/>
                 <a:cs typeface="Aptos"/>
               </a:rPr>
-              <a:t>Evidence</a:t>
+              <a:t>Randomized SMA trial</a:t>
             </a:r>
           </a:p>
         </p:txBody>
@@ -3502,7 +3604,7 @@
                 <a:ea typeface="Aptos"/>
                 <a:cs typeface="Aptos"/>
               </a:rPr>
-              <a:t>Qualitative carrier-mouse blot</a:t>
+              <a:t>Ages 2–12 on SMN therapy</a:t>
             </a:r>
           </a:p>
           <a:p xmlns:a="http://schemas.openxmlformats.org/drawingml/2006/main">
@@ -3526,7 +3628,7 @@
                 <a:ea typeface="Aptos"/>
                 <a:cs typeface="Aptos"/>
               </a:rPr>
-              <a:t>Two mice per genotype</a:t>
+              <a:t>Pooled primary comparison</a:t>
             </a:r>
           </a:p>
           <a:p xmlns:a="http://schemas.openxmlformats.org/drawingml/2006/main">
@@ -3550,7 +3652,7 @@
                 <a:ea typeface="Aptos"/>
                 <a:cs typeface="Aptos"/>
               </a:rPr>
-              <a:t>No phospho/total or statistics</a:t>
+              <a:t>Blocks myostatin activation</a:t>
             </a:r>
           </a:p>
         </p:txBody>
@@ -3608,7 +3710,7 @@
                 <a:ea typeface="Aptos"/>
                 <a:cs typeface="Aptos"/>
               </a:rPr>
-              <a:t>Missing</a:t>
+              <a:t>Limits and risk</a:t>
             </a:r>
           </a:p>
         </p:txBody>
@@ -3666,7 +3768,8 @@
                 <a:ea typeface="Aptos"/>
                 <a:cs typeface="Aptos"/>
               </a:rPr>
-              <a:t>Muscle pathway excess and useful output remain unproved</a:t>
+              <a:t>No demonstrated MVA benefit
+Fractures are a labeled risk</a:t>
             </a:r>
           </a:p>
         </p:txBody>
@@ -3724,7 +3827,7 @@
                 <a:ea typeface="Aptos"/>
                 <a:cs typeface="Aptos"/>
               </a:rPr>
-              <a:t>Rapamycin retained fly stem cells. Functional tissue rescue remains unestablished.</a:t>
+              <a:t>US-approved for SMA with SMN2-targeted therapy. Muscle benefit does not establish chromosome repair.</a:t>
             </a:r>
           </a:p>
         </p:txBody>
@@ -4909,7 +5012,7 @@
                 <a:ea typeface="Aptos"/>
                 <a:cs typeface="Aptos"/>
               </a:rPr>
-              <a:t>Other routes have defined tests for advancement</a:t>
+              <a:t>A broad search changed our comparison</a:t>
             </a:r>
           </a:p>
         </p:txBody>
@@ -4999,7 +5102,7 @@
                     <a:lstStyle/>
                     <a:p>
                       <a:r>
-                        <a:rPr sz="1800" b="1">
+                        <a:rPr sz="1875" b="1">
                           <a:solidFill>
                             <a:srgbClr val="FFFFFF"/>
                           </a:solidFill>
@@ -5007,7 +5110,7 @@
                           <a:ea typeface="Aptos"/>
                           <a:cs typeface="Aptos"/>
                         </a:rPr>
-                        <a:t>Route</a:t>
+                        <a:t>Research role</a:t>
                       </a:r>
                     </a:p>
                   </a:txBody>
@@ -5025,7 +5128,7 @@
                     <a:lstStyle/>
                     <a:p>
                       <a:r>
-                        <a:rPr sz="1800" b="1">
+                        <a:rPr sz="1875" b="1">
                           <a:solidFill>
                             <a:srgbClr val="FFFFFF"/>
                           </a:solidFill>
@@ -5033,7 +5136,7 @@
                           <a:ea typeface="Aptos"/>
                           <a:cs typeface="Aptos"/>
                         </a:rPr>
-                        <a:t>Decision and reason</a:t>
+                        <a:t>Evidence and decision</a:t>
                       </a:r>
                     </a:p>
                   </a:txBody>
@@ -5053,7 +5156,7 @@
                     <a:lstStyle/>
                     <a:p>
                       <a:r>
-                        <a:rPr sz="2025" b="1">
+                        <a:rPr sz="2100" b="1">
                           <a:solidFill>
                             <a:srgbClr val="102E36"/>
                           </a:solidFill>
@@ -5061,7 +5164,7 @@
                           <a:ea typeface="Aptos"/>
                           <a:cs typeface="Aptos"/>
                         </a:rPr>
-                        <a:t>Arimoclomol</a:t>
+                        <a:t>Niacin</a:t>
                       </a:r>
                     </a:p>
                   </a:txBody>
@@ -5079,7 +5182,7 @@
                     <a:lstStyle/>
                     <a:p>
                       <a:r>
-                        <a:rPr sz="2025" b="0">
+                        <a:rPr sz="2100" b="0">
                           <a:solidFill>
                             <a:srgbClr val="102E36"/>
                           </a:solidFill>
@@ -5087,7 +5190,7 @@
                           <a:ea typeface="Aptos"/>
                           <a:cs typeface="Aptos"/>
                         </a:rPr>
-                        <a:t>Reserve: useful BUBR1 rescue and relevant exposure remain unproved</a:t>
+                        <a:t>Retain the BUBR1-restoration hypothesis. Actual-genotype rescue remains unproved.</a:t>
                       </a:r>
                     </a:p>
                   </a:txBody>
@@ -5107,7 +5210,7 @@
                     <a:lstStyle/>
                     <a:p>
                       <a:r>
-                        <a:rPr sz="2025" b="1">
+                        <a:rPr sz="2100" b="1">
                           <a:solidFill>
                             <a:srgbClr val="102E36"/>
                           </a:solidFill>
@@ -5115,7 +5218,7 @@
                           <a:ea typeface="Aptos"/>
                           <a:cs typeface="Aptos"/>
                         </a:rPr>
-                        <a:t>Senolytic medicines</a:t>
+                        <a:t>Apitegromab</a:t>
                       </a:r>
                     </a:p>
                   </a:txBody>
@@ -5133,7 +5236,7 @@
                     <a:lstStyle/>
                     <a:p>
                       <a:r>
-                        <a:rPr sz="2025" b="0">
+                        <a:rPr sz="2100" b="0">
                           <a:solidFill>
                             <a:srgbClr val="102E36"/>
                           </a:solidFill>
@@ -5141,7 +5244,7 @@
                           <a:ea typeface="Aptos"/>
                           <a:cs typeface="Aptos"/>
                         </a:rPr>
-                        <a:t>Reserve: clearing damaged cells can also impair young-muscle repair</a:t>
+                        <a:t>Stronger downstream muscle comparator than everolimus. MVA transfer is unknown.</a:t>
                       </a:r>
                     </a:p>
                   </a:txBody>
@@ -5161,7 +5264,7 @@
                     <a:lstStyle/>
                     <a:p>
                       <a:r>
-                        <a:rPr sz="2025" b="1">
+                        <a:rPr sz="2100" b="1">
                           <a:solidFill>
                             <a:srgbClr val="102E36"/>
                           </a:solidFill>
@@ -5169,7 +5272,7 @@
                           <a:ea typeface="Aptos"/>
                           <a:cs typeface="Aptos"/>
                         </a:rPr>
-                        <a:t>Transcript / protein rescue</a:t>
+                        <a:t>Everolimus</a:t>
                       </a:r>
                     </a:p>
                   </a:txBody>
@@ -5187,7 +5290,7 @@
                     <a:lstStyle/>
                     <a:p>
                       <a:r>
-                        <a:rPr sz="2025" b="0">
+                        <a:rPr sz="2100" b="0">
                           <a:solidFill>
                             <a:srgbClr val="102E36"/>
                           </a:solidFill>
@@ -5195,7 +5298,7 @@
                           <a:ea typeface="Aptos"/>
                           <a:cs typeface="Aptos"/>
                         </a:rPr>
-                        <a:t>Measure the actual allele products before selecting an intervention</a:t>
+                        <a:t>Conditional signaling probe. Relevant pathway excess and functional benefit remain unproved.</a:t>
                       </a:r>
                     </a:p>
                   </a:txBody>
@@ -5263,7 +5366,8 @@
                 <a:ea typeface="Aptos"/>
                 <a:cs typeface="Aptos"/>
               </a:rPr>
-              <a:t>The report compares every route and specifies what would change each decision.</a:t>
+              <a:t>Over 15,000 clinical and regulatory entries screened.
+Missing evidence remains unknown.</a:t>
             </a:r>
           </a:p>
         </p:txBody>
@@ -5794,7 +5898,8 @@
                 <a:ea typeface="Aptos"/>
                 <a:cs typeface="Aptos"/>
               </a:rPr>
-              <a:t>Niacin leads. Useful muscle and preserved renewal decide advancement.</a:t>
+              <a:t>Niacin restoration and apitegromab muscle compensation.
+Test each medicine separately.</a:t>
             </a:r>
           </a:p>
         </p:txBody>
@@ -5852,7 +5957,7 @@
                 <a:ea typeface="Aptos"/>
                 <a:cs typeface="Aptos"/>
               </a:rPr>
-              <a:t>No biological drug experiment has run. Synthetic narration: Cartesia Skylar.</a:t>
+              <a:t>No biological drug experiment has run.</a:t>
             </a:r>
           </a:p>
         </p:txBody>

</xml_diff>